<commit_message>
Update course materials: CMP 417 & DHS 413
Update Distributed Database docx for CMP 417 and add a PDF export; include an Office temporary lock file (~$...) in CMP 417. Update LECTURE PLANNING.pptx for DHS 413 and add a new Project Communications.pptx. These changes refresh course materials and supply a PDF version for CMP 417.
</commit_message>
<xml_diff>
--- a/DHS 413/LECTURE PLANNING.pptx
+++ b/DHS 413/LECTURE PLANNING.pptx
@@ -1,30 +1,30 @@
 
 <file path=ppt/presentation.xml><?xml version="1.0" encoding="utf-8"?>
-<p:presentation xmlns:a="http://schemas.openxmlformats.org/drawingml/2006/main" xmlns:r="http://schemas.openxmlformats.org/officeDocument/2006/relationships" xmlns:p="http://schemas.openxmlformats.org/presentationml/2006/main" saveSubsetFonts="1">
+<p:presentation xmlns:a="http://schemas.openxmlformats.org/drawingml/2006/main" xmlns:r="http://schemas.openxmlformats.org/officeDocument/2006/relationships" xmlns:p="http://schemas.openxmlformats.org/presentationml/2006/main">
   <p:sldMasterIdLst>
-    <p:sldMasterId id="2147483673" r:id="rId1"/>
+    <p:sldMasterId id="2147483648" r:id="rId1"/>
   </p:sldMasterIdLst>
   <p:notesMasterIdLst>
-    <p:notesMasterId r:id="rId19"/>
+    <p:notesMasterId r:id="rId12"/>
   </p:notesMasterIdLst>
   <p:sldIdLst>
-    <p:sldId id="266" r:id="rId2"/>
-    <p:sldId id="6229" r:id="rId3"/>
-    <p:sldId id="6221" r:id="rId4"/>
-    <p:sldId id="6238" r:id="rId5"/>
-    <p:sldId id="6250" r:id="rId6"/>
-    <p:sldId id="6260" r:id="rId7"/>
-    <p:sldId id="6200" r:id="rId8"/>
-    <p:sldId id="6201" r:id="rId9"/>
-    <p:sldId id="6232" r:id="rId10"/>
-    <p:sldId id="6202" r:id="rId11"/>
-    <p:sldId id="6203" r:id="rId12"/>
-    <p:sldId id="6264" r:id="rId13"/>
-    <p:sldId id="6261" r:id="rId14"/>
-    <p:sldId id="6263" r:id="rId15"/>
-    <p:sldId id="6262" r:id="rId16"/>
-    <p:sldId id="6234" r:id="rId17"/>
-    <p:sldId id="6265" r:id="rId18"/>
+    <p:sldId id="266" r:id="rId3"/>
+    <p:sldId id="6229" r:id="rId4"/>
+    <p:sldId id="6221" r:id="rId5"/>
+    <p:sldId id="6238" r:id="rId6"/>
+    <p:sldId id="6250" r:id="rId7"/>
+    <p:sldId id="6260" r:id="rId8"/>
+    <p:sldId id="6200" r:id="rId9"/>
+    <p:sldId id="6201" r:id="rId10"/>
+    <p:sldId id="6232" r:id="rId11"/>
+    <p:sldId id="6202" r:id="rId13"/>
+    <p:sldId id="6203" r:id="rId14"/>
+    <p:sldId id="6264" r:id="rId15"/>
+    <p:sldId id="6261" r:id="rId16"/>
+    <p:sldId id="6263" r:id="rId17"/>
+    <p:sldId id="6262" r:id="rId18"/>
+    <p:sldId id="6234" r:id="rId19"/>
+    <p:sldId id="6265" r:id="rId20"/>
   </p:sldIdLst>
   <p:sldSz cx="12192000" cy="6858000"/>
   <p:notesSz cx="6858000" cy="9144000"/>
@@ -126,12 +126,12 @@
   <p:extLst>
     <p:ext uri="{EFAFB233-063F-42B5-8137-9DF3F51BA10A}">
       <p15:sldGuideLst xmlns:p15="http://schemas.microsoft.com/office/powerpoint/2012/main">
-        <p15:guide id="1" orient="horz" pos="2160">
+        <p15:guide id="1" orient="horz" pos="2160" userDrawn="1">
           <p15:clr>
             <a:srgbClr val="A4A3A4"/>
           </p15:clr>
         </p15:guide>
-        <p15:guide id="2" pos="3840">
+        <p15:guide id="2" pos="3840" userDrawn="1">
           <p15:clr>
             <a:srgbClr val="A4A3A4"/>
           </p15:clr>
@@ -224,7 +224,6 @@
           <a:p>
             <a:fld id="{B9F2D4B9-F4B5-4337-A3E9-E4B73A033AA2}" type="datetimeFigureOut">
               <a:rPr lang="x-none" smtClean="0"/>
-              <a:t>1/20/2026</a:t>
             </a:fld>
             <a:endParaRPr lang="x-none"/>
           </a:p>
@@ -291,6 +290,7 @@
               <a:rPr lang="en-US"/>
               <a:t>Edit Master text styles</a:t>
             </a:r>
+            <a:endParaRPr lang="en-US"/>
           </a:p>
           <a:p>
             <a:pPr lvl="1"/>
@@ -298,6 +298,7 @@
               <a:rPr lang="en-US"/>
               <a:t>Second level</a:t>
             </a:r>
+            <a:endParaRPr lang="en-US"/>
           </a:p>
           <a:p>
             <a:pPr lvl="2"/>
@@ -305,6 +306,7 @@
               <a:rPr lang="en-US"/>
               <a:t>Third level</a:t>
             </a:r>
+            <a:endParaRPr lang="en-US"/>
           </a:p>
           <a:p>
             <a:pPr lvl="3"/>
@@ -312,6 +314,7 @@
               <a:rPr lang="en-US"/>
               <a:t>Fourth level</a:t>
             </a:r>
+            <a:endParaRPr lang="en-US"/>
           </a:p>
           <a:p>
             <a:pPr lvl="4"/>
@@ -383,18 +386,12 @@
           <a:p>
             <a:fld id="{BD29A665-9C52-41F4-B40D-1A983D2C0417}" type="slidenum">
               <a:rPr lang="x-none" smtClean="0"/>
-              <a:t>‹#›</a:t>
             </a:fld>
             <a:endParaRPr lang="x-none"/>
           </a:p>
         </p:txBody>
       </p:sp>
     </p:spTree>
-    <p:extLst>
-      <p:ext uri="{BB962C8B-B14F-4D97-AF65-F5344CB8AC3E}">
-        <p14:creationId xmlns:p14="http://schemas.microsoft.com/office/powerpoint/2010/main" val="3593605433"/>
-      </p:ext>
-    </p:extLst>
   </p:cSld>
   <p:clrMap bg1="lt1" tx1="dk1" bg2="lt2" tx2="dk2" accent1="accent1" accent2="accent2" accent3="accent3" accent4="accent4" accent5="accent5" accent6="accent6" hlink="hlink" folHlink="folHlink"/>
   <p:notesStyle>
@@ -557,18 +554,12 @@
           <a:p>
             <a:fld id="{F9034249-3CC6-4568-BC5D-8238B8560D50}" type="slidenum">
               <a:rPr lang="en-US" smtClean="0"/>
-              <a:t>9</a:t>
             </a:fld>
             <a:endParaRPr lang="en-US"/>
           </a:p>
         </p:txBody>
       </p:sp>
     </p:spTree>
-    <p:extLst>
-      <p:ext uri="{BB962C8B-B14F-4D97-AF65-F5344CB8AC3E}">
-        <p14:creationId xmlns:p14="http://schemas.microsoft.com/office/powerpoint/2010/main" val="4210436855"/>
-      </p:ext>
-    </p:extLst>
   </p:cSld>
   <p:clrMapOvr>
     <a:masterClrMapping/>
@@ -641,19 +632,12 @@
           <a:p>
             <a:fld id="{473023A5-3519-432C-86E6-736807A1BF69}" type="slidenum">
               <a:rPr lang="en-US" smtClean="0"/>
-              <a:pPr/>
-              <a:t>11</a:t>
             </a:fld>
             <a:endParaRPr lang="en-US"/>
           </a:p>
         </p:txBody>
       </p:sp>
     </p:spTree>
-    <p:extLst>
-      <p:ext uri="{BB962C8B-B14F-4D97-AF65-F5344CB8AC3E}">
-        <p14:creationId xmlns:p14="http://schemas.microsoft.com/office/powerpoint/2010/main" val="4240576291"/>
-      </p:ext>
-    </p:extLst>
   </p:cSld>
   <p:clrMapOvr>
     <a:masterClrMapping/>
@@ -680,13 +664,7 @@
       </p:grpSpPr>
       <p:sp>
         <p:nvSpPr>
-          <p:cNvPr id="2" name="Title 1">
-            <a:extLst>
-              <a:ext uri="{FF2B5EF4-FFF2-40B4-BE49-F238E27FC236}">
-                <a16:creationId xmlns:a16="http://schemas.microsoft.com/office/drawing/2014/main" id="{E6EA1817-FD97-9C24-199A-187912D3D6D2}"/>
-              </a:ext>
-            </a:extLst>
-          </p:cNvPr>
+          <p:cNvPr id="2" name="Title 1"/>
           <p:cNvSpPr>
             <a:spLocks noGrp="1"/>
           </p:cNvSpPr>
@@ -712,18 +690,13 @@
               <a:rPr lang="en-US"/>
               <a:t>Click to edit Master title style</a:t>
             </a:r>
+            <a:endParaRPr lang="en-US"/>
           </a:p>
         </p:txBody>
       </p:sp>
       <p:sp>
         <p:nvSpPr>
-          <p:cNvPr id="3" name="Subtitle 2">
-            <a:extLst>
-              <a:ext uri="{FF2B5EF4-FFF2-40B4-BE49-F238E27FC236}">
-                <a16:creationId xmlns:a16="http://schemas.microsoft.com/office/drawing/2014/main" id="{3F3181B5-8D2D-78B4-8783-56ED27AA1311}"/>
-              </a:ext>
-            </a:extLst>
-          </p:cNvPr>
+          <p:cNvPr id="3" name="Subtitle 2"/>
           <p:cNvSpPr>
             <a:spLocks noGrp="1"/>
           </p:cNvSpPr>
@@ -782,18 +755,13 @@
               <a:rPr lang="en-US"/>
               <a:t>Click to edit Master subtitle style</a:t>
             </a:r>
+            <a:endParaRPr lang="en-US"/>
           </a:p>
         </p:txBody>
       </p:sp>
       <p:sp>
         <p:nvSpPr>
-          <p:cNvPr id="4" name="Date Placeholder 3">
-            <a:extLst>
-              <a:ext uri="{FF2B5EF4-FFF2-40B4-BE49-F238E27FC236}">
-                <a16:creationId xmlns:a16="http://schemas.microsoft.com/office/drawing/2014/main" id="{ABFC9960-77E2-ADDD-5AAF-95496327716F}"/>
-              </a:ext>
-            </a:extLst>
-          </p:cNvPr>
+          <p:cNvPr id="4" name="Date Placeholder 3"/>
           <p:cNvSpPr>
             <a:spLocks noGrp="1"/>
           </p:cNvSpPr>
@@ -808,7 +776,6 @@
           <a:p>
             <a:fld id="{F97F9DE9-0176-4232-90F5-7CEFD5A2742E}" type="datetimeFigureOut">
               <a:rPr lang="x-none" smtClean="0"/>
-              <a:t>1/20/2026</a:t>
             </a:fld>
             <a:endParaRPr lang="x-none"/>
           </a:p>
@@ -816,13 +783,7 @@
       </p:sp>
       <p:sp>
         <p:nvSpPr>
-          <p:cNvPr id="5" name="Footer Placeholder 4">
-            <a:extLst>
-              <a:ext uri="{FF2B5EF4-FFF2-40B4-BE49-F238E27FC236}">
-                <a16:creationId xmlns:a16="http://schemas.microsoft.com/office/drawing/2014/main" id="{891AA92B-2DF9-1EB3-F109-F9F72018C51C}"/>
-              </a:ext>
-            </a:extLst>
-          </p:cNvPr>
+          <p:cNvPr id="5" name="Footer Placeholder 4"/>
           <p:cNvSpPr>
             <a:spLocks noGrp="1"/>
           </p:cNvSpPr>
@@ -841,13 +802,7 @@
       </p:sp>
       <p:sp>
         <p:nvSpPr>
-          <p:cNvPr id="6" name="Slide Number Placeholder 5">
-            <a:extLst>
-              <a:ext uri="{FF2B5EF4-FFF2-40B4-BE49-F238E27FC236}">
-                <a16:creationId xmlns:a16="http://schemas.microsoft.com/office/drawing/2014/main" id="{6CF81547-CC53-0FBC-2D37-54515C4A1B6B}"/>
-              </a:ext>
-            </a:extLst>
-          </p:cNvPr>
+          <p:cNvPr id="6" name="Slide Number Placeholder 5"/>
           <p:cNvSpPr>
             <a:spLocks noGrp="1"/>
           </p:cNvSpPr>
@@ -862,18 +817,12 @@
           <a:p>
             <a:fld id="{1EA25AC8-EF13-4E35-A362-B896E37E3AA9}" type="slidenum">
               <a:rPr lang="x-none" smtClean="0"/>
-              <a:t>‹#›</a:t>
             </a:fld>
             <a:endParaRPr lang="x-none"/>
           </a:p>
         </p:txBody>
       </p:sp>
     </p:spTree>
-    <p:extLst>
-      <p:ext uri="{BB962C8B-B14F-4D97-AF65-F5344CB8AC3E}">
-        <p14:creationId xmlns:p14="http://schemas.microsoft.com/office/powerpoint/2010/main" val="2854301722"/>
-      </p:ext>
-    </p:extLst>
   </p:cSld>
   <p:clrMapOvr>
     <a:masterClrMapping/>
@@ -900,13 +849,7 @@
       </p:grpSpPr>
       <p:sp>
         <p:nvSpPr>
-          <p:cNvPr id="2" name="Title 1">
-            <a:extLst>
-              <a:ext uri="{FF2B5EF4-FFF2-40B4-BE49-F238E27FC236}">
-                <a16:creationId xmlns:a16="http://schemas.microsoft.com/office/drawing/2014/main" id="{B931EC45-0DCE-EDC0-3991-8E8A42C287C8}"/>
-              </a:ext>
-            </a:extLst>
-          </p:cNvPr>
+          <p:cNvPr id="2" name="Title 1"/>
           <p:cNvSpPr>
             <a:spLocks noGrp="1"/>
           </p:cNvSpPr>
@@ -923,18 +866,13 @@
               <a:rPr lang="en-US"/>
               <a:t>Click to edit Master title style</a:t>
             </a:r>
+            <a:endParaRPr lang="en-US"/>
           </a:p>
         </p:txBody>
       </p:sp>
       <p:sp>
         <p:nvSpPr>
-          <p:cNvPr id="3" name="Vertical Text Placeholder 2">
-            <a:extLst>
-              <a:ext uri="{FF2B5EF4-FFF2-40B4-BE49-F238E27FC236}">
-                <a16:creationId xmlns:a16="http://schemas.microsoft.com/office/drawing/2014/main" id="{FDD912B2-F3F1-65ED-D4AE-F752365554C2}"/>
-              </a:ext>
-            </a:extLst>
-          </p:cNvPr>
+          <p:cNvPr id="3" name="Vertical Text Placeholder 2"/>
           <p:cNvSpPr>
             <a:spLocks noGrp="1"/>
           </p:cNvSpPr>
@@ -952,6 +890,7 @@
               <a:rPr lang="en-US"/>
               <a:t>Click to edit Master text styles</a:t>
             </a:r>
+            <a:endParaRPr lang="en-US"/>
           </a:p>
           <a:p>
             <a:pPr lvl="1"/>
@@ -959,6 +898,7 @@
               <a:rPr lang="en-US"/>
               <a:t>Second level</a:t>
             </a:r>
+            <a:endParaRPr lang="en-US"/>
           </a:p>
           <a:p>
             <a:pPr lvl="2"/>
@@ -966,6 +906,7 @@
               <a:rPr lang="en-US"/>
               <a:t>Third level</a:t>
             </a:r>
+            <a:endParaRPr lang="en-US"/>
           </a:p>
           <a:p>
             <a:pPr lvl="3"/>
@@ -973,6 +914,7 @@
               <a:rPr lang="en-US"/>
               <a:t>Fourth level</a:t>
             </a:r>
+            <a:endParaRPr lang="en-US"/>
           </a:p>
           <a:p>
             <a:pPr lvl="4"/>
@@ -980,18 +922,13 @@
               <a:rPr lang="en-US"/>
               <a:t>Fifth level</a:t>
             </a:r>
+            <a:endParaRPr lang="en-US"/>
           </a:p>
         </p:txBody>
       </p:sp>
       <p:sp>
         <p:nvSpPr>
-          <p:cNvPr id="4" name="Date Placeholder 3">
-            <a:extLst>
-              <a:ext uri="{FF2B5EF4-FFF2-40B4-BE49-F238E27FC236}">
-                <a16:creationId xmlns:a16="http://schemas.microsoft.com/office/drawing/2014/main" id="{24249D8C-8BF9-FE46-52C6-EEEB776F4FA3}"/>
-              </a:ext>
-            </a:extLst>
-          </p:cNvPr>
+          <p:cNvPr id="4" name="Date Placeholder 3"/>
           <p:cNvSpPr>
             <a:spLocks noGrp="1"/>
           </p:cNvSpPr>
@@ -1006,7 +943,6 @@
           <a:p>
             <a:fld id="{F97F9DE9-0176-4232-90F5-7CEFD5A2742E}" type="datetimeFigureOut">
               <a:rPr lang="x-none" smtClean="0"/>
-              <a:t>1/20/2026</a:t>
             </a:fld>
             <a:endParaRPr lang="x-none"/>
           </a:p>
@@ -1014,13 +950,7 @@
       </p:sp>
       <p:sp>
         <p:nvSpPr>
-          <p:cNvPr id="5" name="Footer Placeholder 4">
-            <a:extLst>
-              <a:ext uri="{FF2B5EF4-FFF2-40B4-BE49-F238E27FC236}">
-                <a16:creationId xmlns:a16="http://schemas.microsoft.com/office/drawing/2014/main" id="{8AB1173F-D191-02ED-D527-F41C1B26249B}"/>
-              </a:ext>
-            </a:extLst>
-          </p:cNvPr>
+          <p:cNvPr id="5" name="Footer Placeholder 4"/>
           <p:cNvSpPr>
             <a:spLocks noGrp="1"/>
           </p:cNvSpPr>
@@ -1039,13 +969,7 @@
       </p:sp>
       <p:sp>
         <p:nvSpPr>
-          <p:cNvPr id="6" name="Slide Number Placeholder 5">
-            <a:extLst>
-              <a:ext uri="{FF2B5EF4-FFF2-40B4-BE49-F238E27FC236}">
-                <a16:creationId xmlns:a16="http://schemas.microsoft.com/office/drawing/2014/main" id="{5D041342-313B-0E62-FFF2-01BA21BDB0A8}"/>
-              </a:ext>
-            </a:extLst>
-          </p:cNvPr>
+          <p:cNvPr id="6" name="Slide Number Placeholder 5"/>
           <p:cNvSpPr>
             <a:spLocks noGrp="1"/>
           </p:cNvSpPr>
@@ -1060,18 +984,12 @@
           <a:p>
             <a:fld id="{1EA25AC8-EF13-4E35-A362-B896E37E3AA9}" type="slidenum">
               <a:rPr lang="x-none" smtClean="0"/>
-              <a:t>‹#›</a:t>
             </a:fld>
             <a:endParaRPr lang="x-none"/>
           </a:p>
         </p:txBody>
       </p:sp>
     </p:spTree>
-    <p:extLst>
-      <p:ext uri="{BB962C8B-B14F-4D97-AF65-F5344CB8AC3E}">
-        <p14:creationId xmlns:p14="http://schemas.microsoft.com/office/powerpoint/2010/main" val="1145649516"/>
-      </p:ext>
-    </p:extLst>
   </p:cSld>
   <p:clrMapOvr>
     <a:masterClrMapping/>
@@ -1098,13 +1016,7 @@
       </p:grpSpPr>
       <p:sp>
         <p:nvSpPr>
-          <p:cNvPr id="2" name="Vertical Title 1">
-            <a:extLst>
-              <a:ext uri="{FF2B5EF4-FFF2-40B4-BE49-F238E27FC236}">
-                <a16:creationId xmlns:a16="http://schemas.microsoft.com/office/drawing/2014/main" id="{53DBD672-26EF-546F-62EF-F9802B02663C}"/>
-              </a:ext>
-            </a:extLst>
-          </p:cNvPr>
+          <p:cNvPr id="2" name="Vertical Title 1"/>
           <p:cNvSpPr>
             <a:spLocks noGrp="1"/>
           </p:cNvSpPr>
@@ -1126,18 +1038,13 @@
               <a:rPr lang="en-US"/>
               <a:t>Click to edit Master title style</a:t>
             </a:r>
+            <a:endParaRPr lang="en-US"/>
           </a:p>
         </p:txBody>
       </p:sp>
       <p:sp>
         <p:nvSpPr>
-          <p:cNvPr id="3" name="Vertical Text Placeholder 2">
-            <a:extLst>
-              <a:ext uri="{FF2B5EF4-FFF2-40B4-BE49-F238E27FC236}">
-                <a16:creationId xmlns:a16="http://schemas.microsoft.com/office/drawing/2014/main" id="{1B848F0C-418F-9A89-1386-5C669AF5D021}"/>
-              </a:ext>
-            </a:extLst>
-          </p:cNvPr>
+          <p:cNvPr id="3" name="Vertical Text Placeholder 2"/>
           <p:cNvSpPr>
             <a:spLocks noGrp="1"/>
           </p:cNvSpPr>
@@ -1160,6 +1067,7 @@
               <a:rPr lang="en-US"/>
               <a:t>Click to edit Master text styles</a:t>
             </a:r>
+            <a:endParaRPr lang="en-US"/>
           </a:p>
           <a:p>
             <a:pPr lvl="1"/>
@@ -1167,6 +1075,7 @@
               <a:rPr lang="en-US"/>
               <a:t>Second level</a:t>
             </a:r>
+            <a:endParaRPr lang="en-US"/>
           </a:p>
           <a:p>
             <a:pPr lvl="2"/>
@@ -1174,6 +1083,7 @@
               <a:rPr lang="en-US"/>
               <a:t>Third level</a:t>
             </a:r>
+            <a:endParaRPr lang="en-US"/>
           </a:p>
           <a:p>
             <a:pPr lvl="3"/>
@@ -1181,6 +1091,7 @@
               <a:rPr lang="en-US"/>
               <a:t>Fourth level</a:t>
             </a:r>
+            <a:endParaRPr lang="en-US"/>
           </a:p>
           <a:p>
             <a:pPr lvl="4"/>
@@ -1188,18 +1099,13 @@
               <a:rPr lang="en-US"/>
               <a:t>Fifth level</a:t>
             </a:r>
+            <a:endParaRPr lang="en-US"/>
           </a:p>
         </p:txBody>
       </p:sp>
       <p:sp>
         <p:nvSpPr>
-          <p:cNvPr id="4" name="Date Placeholder 3">
-            <a:extLst>
-              <a:ext uri="{FF2B5EF4-FFF2-40B4-BE49-F238E27FC236}">
-                <a16:creationId xmlns:a16="http://schemas.microsoft.com/office/drawing/2014/main" id="{4851B7F3-2F5F-3EB7-84F9-6FC28A788ACA}"/>
-              </a:ext>
-            </a:extLst>
-          </p:cNvPr>
+          <p:cNvPr id="4" name="Date Placeholder 3"/>
           <p:cNvSpPr>
             <a:spLocks noGrp="1"/>
           </p:cNvSpPr>
@@ -1214,7 +1120,6 @@
           <a:p>
             <a:fld id="{F97F9DE9-0176-4232-90F5-7CEFD5A2742E}" type="datetimeFigureOut">
               <a:rPr lang="x-none" smtClean="0"/>
-              <a:t>1/20/2026</a:t>
             </a:fld>
             <a:endParaRPr lang="x-none"/>
           </a:p>
@@ -1222,13 +1127,7 @@
       </p:sp>
       <p:sp>
         <p:nvSpPr>
-          <p:cNvPr id="5" name="Footer Placeholder 4">
-            <a:extLst>
-              <a:ext uri="{FF2B5EF4-FFF2-40B4-BE49-F238E27FC236}">
-                <a16:creationId xmlns:a16="http://schemas.microsoft.com/office/drawing/2014/main" id="{3C9B56A8-7711-5A1B-DA90-4953071B6495}"/>
-              </a:ext>
-            </a:extLst>
-          </p:cNvPr>
+          <p:cNvPr id="5" name="Footer Placeholder 4"/>
           <p:cNvSpPr>
             <a:spLocks noGrp="1"/>
           </p:cNvSpPr>
@@ -1247,13 +1146,7 @@
       </p:sp>
       <p:sp>
         <p:nvSpPr>
-          <p:cNvPr id="6" name="Slide Number Placeholder 5">
-            <a:extLst>
-              <a:ext uri="{FF2B5EF4-FFF2-40B4-BE49-F238E27FC236}">
-                <a16:creationId xmlns:a16="http://schemas.microsoft.com/office/drawing/2014/main" id="{D2CBAA33-5FDA-F182-FA38-A0AA67CB0719}"/>
-              </a:ext>
-            </a:extLst>
-          </p:cNvPr>
+          <p:cNvPr id="6" name="Slide Number Placeholder 5"/>
           <p:cNvSpPr>
             <a:spLocks noGrp="1"/>
           </p:cNvSpPr>
@@ -1268,18 +1161,12 @@
           <a:p>
             <a:fld id="{1EA25AC8-EF13-4E35-A362-B896E37E3AA9}" type="slidenum">
               <a:rPr lang="x-none" smtClean="0"/>
-              <a:t>‹#›</a:t>
             </a:fld>
             <a:endParaRPr lang="x-none"/>
           </a:p>
         </p:txBody>
       </p:sp>
     </p:spTree>
-    <p:extLst>
-      <p:ext uri="{BB962C8B-B14F-4D97-AF65-F5344CB8AC3E}">
-        <p14:creationId xmlns:p14="http://schemas.microsoft.com/office/powerpoint/2010/main" val="2461606549"/>
-      </p:ext>
-    </p:extLst>
   </p:cSld>
   <p:clrMapOvr>
     <a:masterClrMapping/>
@@ -1306,16 +1193,7 @@
       </p:grpSpPr>
       <p:pic>
         <p:nvPicPr>
-          <p:cNvPr id="7" name="Graphic 6">
-            <a:extLst>
-              <a:ext uri="{FF2B5EF4-FFF2-40B4-BE49-F238E27FC236}">
-                <a16:creationId xmlns:a16="http://schemas.microsoft.com/office/drawing/2014/main" id="{AEE644D4-F9A4-4237-BD5C-4B97ABA9337E}"/>
-              </a:ext>
-              <a:ext uri="{C183D7F6-B498-43B3-948B-1728B52AA6E4}">
-                <adec:decorative xmlns:adec="http://schemas.microsoft.com/office/drawing/2017/decorative" val="1"/>
-              </a:ext>
-            </a:extLst>
-          </p:cNvPr>
+          <p:cNvPr id="7" name="Graphic 6"/>
           <p:cNvPicPr>
             <a:picLocks noChangeAspect="1"/>
           </p:cNvPicPr>
@@ -1345,13 +1223,7 @@
       </p:pic>
       <p:sp>
         <p:nvSpPr>
-          <p:cNvPr id="2" name="Title 1">
-            <a:extLst>
-              <a:ext uri="{FF2B5EF4-FFF2-40B4-BE49-F238E27FC236}">
-                <a16:creationId xmlns:a16="http://schemas.microsoft.com/office/drawing/2014/main" id="{C2FF67A8-55FA-435D-A18C-96D63D22B53E}"/>
-              </a:ext>
-            </a:extLst>
-          </p:cNvPr>
+          <p:cNvPr id="2" name="Title 1"/>
           <p:cNvSpPr>
             <a:spLocks noGrp="1"/>
           </p:cNvSpPr>
@@ -1386,18 +1258,13 @@
               <a:rPr lang="en-US"/>
               <a:t>CLICK TO EDIT MASTER TITLE STYLE</a:t>
             </a:r>
+            <a:endParaRPr lang="en-US"/>
           </a:p>
         </p:txBody>
       </p:sp>
       <p:sp>
         <p:nvSpPr>
-          <p:cNvPr id="10" name="Subtitle 2">
-            <a:extLst>
-              <a:ext uri="{FF2B5EF4-FFF2-40B4-BE49-F238E27FC236}">
-                <a16:creationId xmlns:a16="http://schemas.microsoft.com/office/drawing/2014/main" id="{104828DA-5EC5-4A00-9A7B-CD9668EF24D1}"/>
-              </a:ext>
-            </a:extLst>
-          </p:cNvPr>
+          <p:cNvPr id="10" name="Subtitle 2"/>
           <p:cNvSpPr>
             <a:spLocks noGrp="1"/>
           </p:cNvSpPr>
@@ -1464,18 +1331,13 @@
               <a:rPr lang="en-US"/>
               <a:t>Click to edit Master subtitle style</a:t>
             </a:r>
+            <a:endParaRPr lang="en-US"/>
           </a:p>
         </p:txBody>
       </p:sp>
       <p:sp>
         <p:nvSpPr>
-          <p:cNvPr id="3" name="Date Placeholder 2">
-            <a:extLst>
-              <a:ext uri="{FF2B5EF4-FFF2-40B4-BE49-F238E27FC236}">
-                <a16:creationId xmlns:a16="http://schemas.microsoft.com/office/drawing/2014/main" id="{D9303E9A-96BC-4283-A6E1-5948AEB119F4}"/>
-              </a:ext>
-            </a:extLst>
-          </p:cNvPr>
+          <p:cNvPr id="3" name="Date Placeholder 2"/>
           <p:cNvSpPr>
             <a:spLocks noGrp="1"/>
           </p:cNvSpPr>
@@ -1501,18 +1363,13 @@
               <a:rPr lang="en-US" dirty="0"/>
               <a:t>20XX</a:t>
             </a:r>
+            <a:endParaRPr lang="en-US" dirty="0"/>
           </a:p>
         </p:txBody>
       </p:sp>
       <p:sp>
         <p:nvSpPr>
-          <p:cNvPr id="4" name="Footer Placeholder 3">
-            <a:extLst>
-              <a:ext uri="{FF2B5EF4-FFF2-40B4-BE49-F238E27FC236}">
-                <a16:creationId xmlns:a16="http://schemas.microsoft.com/office/drawing/2014/main" id="{45A19C49-052B-4D3E-B227-1D787463CE96}"/>
-              </a:ext>
-            </a:extLst>
-          </p:cNvPr>
+          <p:cNvPr id="4" name="Footer Placeholder 3"/>
           <p:cNvSpPr>
             <a:spLocks noGrp="1"/>
           </p:cNvSpPr>
@@ -1538,18 +1395,13 @@
               <a:rPr lang="en-US" dirty="0"/>
               <a:t>PRESENTATION TITLE</a:t>
             </a:r>
+            <a:endParaRPr lang="en-US" dirty="0"/>
           </a:p>
         </p:txBody>
       </p:sp>
       <p:sp>
         <p:nvSpPr>
-          <p:cNvPr id="5" name="Slide Number Placeholder 4">
-            <a:extLst>
-              <a:ext uri="{FF2B5EF4-FFF2-40B4-BE49-F238E27FC236}">
-                <a16:creationId xmlns:a16="http://schemas.microsoft.com/office/drawing/2014/main" id="{4E5E724A-95F0-41B6-A77E-EDD067272C27}"/>
-              </a:ext>
-            </a:extLst>
-          </p:cNvPr>
+          <p:cNvPr id="5" name="Slide Number Placeholder 4"/>
           <p:cNvSpPr>
             <a:spLocks noGrp="1"/>
           </p:cNvSpPr>
@@ -1573,8 +1425,6 @@
           <a:p>
             <a:fld id="{A49DFD55-3C28-40EF-9E31-A92D2E4017FF}" type="slidenum">
               <a:rPr lang="en-US" smtClean="0"/>
-              <a:pPr/>
-              <a:t>‹#›</a:t>
             </a:fld>
             <a:endParaRPr lang="en-US" dirty="0"/>
           </a:p>
@@ -1582,16 +1432,7 @@
       </p:sp>
       <p:cxnSp>
         <p:nvCxnSpPr>
-          <p:cNvPr id="9" name="Straight Connector 8">
-            <a:extLst>
-              <a:ext uri="{FF2B5EF4-FFF2-40B4-BE49-F238E27FC236}">
-                <a16:creationId xmlns:a16="http://schemas.microsoft.com/office/drawing/2014/main" id="{BDAC7E4E-FE06-4E90-8107-6B543E5515ED}"/>
-              </a:ext>
-              <a:ext uri="{C183D7F6-B498-43B3-948B-1728B52AA6E4}">
-                <adec:decorative xmlns:adec="http://schemas.microsoft.com/office/drawing/2017/decorative" val="1"/>
-              </a:ext>
-            </a:extLst>
-          </p:cNvPr>
+          <p:cNvPr id="9" name="Straight Connector 8"/>
           <p:cNvCxnSpPr/>
           <p:nvPr userDrawn="1"/>
         </p:nvCxnSpPr>
@@ -1625,11 +1466,6 @@
         </p:style>
       </p:cxnSp>
     </p:spTree>
-    <p:extLst>
-      <p:ext uri="{BB962C8B-B14F-4D97-AF65-F5344CB8AC3E}">
-        <p14:creationId xmlns:p14="http://schemas.microsoft.com/office/powerpoint/2010/main" val="2189176229"/>
-      </p:ext>
-    </p:extLst>
   </p:cSld>
   <p:clrMapOvr>
     <a:masterClrMapping/>
@@ -1656,13 +1492,7 @@
       </p:grpSpPr>
       <p:sp>
         <p:nvSpPr>
-          <p:cNvPr id="2" name="Title 1">
-            <a:extLst>
-              <a:ext uri="{FF2B5EF4-FFF2-40B4-BE49-F238E27FC236}">
-                <a16:creationId xmlns:a16="http://schemas.microsoft.com/office/drawing/2014/main" id="{464EC5AA-817A-E0B1-EB21-A41C83926178}"/>
-              </a:ext>
-            </a:extLst>
-          </p:cNvPr>
+          <p:cNvPr id="2" name="Title 1"/>
           <p:cNvSpPr>
             <a:spLocks noGrp="1"/>
           </p:cNvSpPr>
@@ -1679,18 +1509,13 @@
               <a:rPr lang="en-US"/>
               <a:t>Click to edit Master title style</a:t>
             </a:r>
+            <a:endParaRPr lang="en-US"/>
           </a:p>
         </p:txBody>
       </p:sp>
       <p:sp>
         <p:nvSpPr>
-          <p:cNvPr id="3" name="Content Placeholder 2">
-            <a:extLst>
-              <a:ext uri="{FF2B5EF4-FFF2-40B4-BE49-F238E27FC236}">
-                <a16:creationId xmlns:a16="http://schemas.microsoft.com/office/drawing/2014/main" id="{802CF1F6-8463-9B5E-0AB0-88A13C75928D}"/>
-              </a:ext>
-            </a:extLst>
-          </p:cNvPr>
+          <p:cNvPr id="3" name="Content Placeholder 2"/>
           <p:cNvSpPr>
             <a:spLocks noGrp="1"/>
           </p:cNvSpPr>
@@ -1708,6 +1533,7 @@
               <a:rPr lang="en-US"/>
               <a:t>Click to edit Master text styles</a:t>
             </a:r>
+            <a:endParaRPr lang="en-US"/>
           </a:p>
           <a:p>
             <a:pPr lvl="1"/>
@@ -1715,6 +1541,7 @@
               <a:rPr lang="en-US"/>
               <a:t>Second level</a:t>
             </a:r>
+            <a:endParaRPr lang="en-US"/>
           </a:p>
           <a:p>
             <a:pPr lvl="2"/>
@@ -1722,6 +1549,7 @@
               <a:rPr lang="en-US"/>
               <a:t>Third level</a:t>
             </a:r>
+            <a:endParaRPr lang="en-US"/>
           </a:p>
           <a:p>
             <a:pPr lvl="3"/>
@@ -1729,6 +1557,7 @@
               <a:rPr lang="en-US"/>
               <a:t>Fourth level</a:t>
             </a:r>
+            <a:endParaRPr lang="en-US"/>
           </a:p>
           <a:p>
             <a:pPr lvl="4"/>
@@ -1736,18 +1565,13 @@
               <a:rPr lang="en-US"/>
               <a:t>Fifth level</a:t>
             </a:r>
+            <a:endParaRPr lang="en-US"/>
           </a:p>
         </p:txBody>
       </p:sp>
       <p:sp>
         <p:nvSpPr>
-          <p:cNvPr id="4" name="Date Placeholder 3">
-            <a:extLst>
-              <a:ext uri="{FF2B5EF4-FFF2-40B4-BE49-F238E27FC236}">
-                <a16:creationId xmlns:a16="http://schemas.microsoft.com/office/drawing/2014/main" id="{DAA4F477-0135-5B62-8278-63DD8A48FB9F}"/>
-              </a:ext>
-            </a:extLst>
-          </p:cNvPr>
+          <p:cNvPr id="4" name="Date Placeholder 3"/>
           <p:cNvSpPr>
             <a:spLocks noGrp="1"/>
           </p:cNvSpPr>
@@ -1762,7 +1586,6 @@
           <a:p>
             <a:fld id="{F97F9DE9-0176-4232-90F5-7CEFD5A2742E}" type="datetimeFigureOut">
               <a:rPr lang="x-none" smtClean="0"/>
-              <a:t>1/20/2026</a:t>
             </a:fld>
             <a:endParaRPr lang="x-none"/>
           </a:p>
@@ -1770,13 +1593,7 @@
       </p:sp>
       <p:sp>
         <p:nvSpPr>
-          <p:cNvPr id="5" name="Footer Placeholder 4">
-            <a:extLst>
-              <a:ext uri="{FF2B5EF4-FFF2-40B4-BE49-F238E27FC236}">
-                <a16:creationId xmlns:a16="http://schemas.microsoft.com/office/drawing/2014/main" id="{21562AB1-B2E7-5A53-670B-43868C4FBD34}"/>
-              </a:ext>
-            </a:extLst>
-          </p:cNvPr>
+          <p:cNvPr id="5" name="Footer Placeholder 4"/>
           <p:cNvSpPr>
             <a:spLocks noGrp="1"/>
           </p:cNvSpPr>
@@ -1795,13 +1612,7 @@
       </p:sp>
       <p:sp>
         <p:nvSpPr>
-          <p:cNvPr id="6" name="Slide Number Placeholder 5">
-            <a:extLst>
-              <a:ext uri="{FF2B5EF4-FFF2-40B4-BE49-F238E27FC236}">
-                <a16:creationId xmlns:a16="http://schemas.microsoft.com/office/drawing/2014/main" id="{B8338700-4494-D90E-EB08-335BE896AF5B}"/>
-              </a:ext>
-            </a:extLst>
-          </p:cNvPr>
+          <p:cNvPr id="6" name="Slide Number Placeholder 5"/>
           <p:cNvSpPr>
             <a:spLocks noGrp="1"/>
           </p:cNvSpPr>
@@ -1816,18 +1627,12 @@
           <a:p>
             <a:fld id="{1EA25AC8-EF13-4E35-A362-B896E37E3AA9}" type="slidenum">
               <a:rPr lang="x-none" smtClean="0"/>
-              <a:t>‹#›</a:t>
             </a:fld>
             <a:endParaRPr lang="x-none"/>
           </a:p>
         </p:txBody>
       </p:sp>
     </p:spTree>
-    <p:extLst>
-      <p:ext uri="{BB962C8B-B14F-4D97-AF65-F5344CB8AC3E}">
-        <p14:creationId xmlns:p14="http://schemas.microsoft.com/office/powerpoint/2010/main" val="2176873925"/>
-      </p:ext>
-    </p:extLst>
   </p:cSld>
   <p:clrMapOvr>
     <a:masterClrMapping/>
@@ -1854,13 +1659,7 @@
       </p:grpSpPr>
       <p:sp>
         <p:nvSpPr>
-          <p:cNvPr id="2" name="Title 1">
-            <a:extLst>
-              <a:ext uri="{FF2B5EF4-FFF2-40B4-BE49-F238E27FC236}">
-                <a16:creationId xmlns:a16="http://schemas.microsoft.com/office/drawing/2014/main" id="{B0DF827E-E2E0-79AA-6418-B73CEDCF5E4F}"/>
-              </a:ext>
-            </a:extLst>
-          </p:cNvPr>
+          <p:cNvPr id="2" name="Title 1"/>
           <p:cNvSpPr>
             <a:spLocks noGrp="1"/>
           </p:cNvSpPr>
@@ -1886,18 +1685,13 @@
               <a:rPr lang="en-US"/>
               <a:t>Click to edit Master title style</a:t>
             </a:r>
+            <a:endParaRPr lang="en-US"/>
           </a:p>
         </p:txBody>
       </p:sp>
       <p:sp>
         <p:nvSpPr>
-          <p:cNvPr id="3" name="Text Placeholder 2">
-            <a:extLst>
-              <a:ext uri="{FF2B5EF4-FFF2-40B4-BE49-F238E27FC236}">
-                <a16:creationId xmlns:a16="http://schemas.microsoft.com/office/drawing/2014/main" id="{A4A292EF-8099-B55E-A5CE-A220A80DF74F}"/>
-              </a:ext>
-            </a:extLst>
-          </p:cNvPr>
+          <p:cNvPr id="3" name="Text Placeholder 2"/>
           <p:cNvSpPr>
             <a:spLocks noGrp="1"/>
           </p:cNvSpPr>
@@ -2011,18 +1805,13 @@
               <a:rPr lang="en-US"/>
               <a:t>Click to edit Master text styles</a:t>
             </a:r>
+            <a:endParaRPr lang="en-US"/>
           </a:p>
         </p:txBody>
       </p:sp>
       <p:sp>
         <p:nvSpPr>
-          <p:cNvPr id="4" name="Date Placeholder 3">
-            <a:extLst>
-              <a:ext uri="{FF2B5EF4-FFF2-40B4-BE49-F238E27FC236}">
-                <a16:creationId xmlns:a16="http://schemas.microsoft.com/office/drawing/2014/main" id="{56CAEF8A-BD87-11E6-5A26-2BF40DEF281E}"/>
-              </a:ext>
-            </a:extLst>
-          </p:cNvPr>
+          <p:cNvPr id="4" name="Date Placeholder 3"/>
           <p:cNvSpPr>
             <a:spLocks noGrp="1"/>
           </p:cNvSpPr>
@@ -2037,7 +1826,6 @@
           <a:p>
             <a:fld id="{F97F9DE9-0176-4232-90F5-7CEFD5A2742E}" type="datetimeFigureOut">
               <a:rPr lang="x-none" smtClean="0"/>
-              <a:t>1/20/2026</a:t>
             </a:fld>
             <a:endParaRPr lang="x-none"/>
           </a:p>
@@ -2045,13 +1833,7 @@
       </p:sp>
       <p:sp>
         <p:nvSpPr>
-          <p:cNvPr id="5" name="Footer Placeholder 4">
-            <a:extLst>
-              <a:ext uri="{FF2B5EF4-FFF2-40B4-BE49-F238E27FC236}">
-                <a16:creationId xmlns:a16="http://schemas.microsoft.com/office/drawing/2014/main" id="{6CF4B75D-8B53-2F79-C12E-FBCD005DFF5A}"/>
-              </a:ext>
-            </a:extLst>
-          </p:cNvPr>
+          <p:cNvPr id="5" name="Footer Placeholder 4"/>
           <p:cNvSpPr>
             <a:spLocks noGrp="1"/>
           </p:cNvSpPr>
@@ -2070,13 +1852,7 @@
       </p:sp>
       <p:sp>
         <p:nvSpPr>
-          <p:cNvPr id="6" name="Slide Number Placeholder 5">
-            <a:extLst>
-              <a:ext uri="{FF2B5EF4-FFF2-40B4-BE49-F238E27FC236}">
-                <a16:creationId xmlns:a16="http://schemas.microsoft.com/office/drawing/2014/main" id="{7244A264-D194-9714-47A7-18BB17571395}"/>
-              </a:ext>
-            </a:extLst>
-          </p:cNvPr>
+          <p:cNvPr id="6" name="Slide Number Placeholder 5"/>
           <p:cNvSpPr>
             <a:spLocks noGrp="1"/>
           </p:cNvSpPr>
@@ -2091,18 +1867,12 @@
           <a:p>
             <a:fld id="{1EA25AC8-EF13-4E35-A362-B896E37E3AA9}" type="slidenum">
               <a:rPr lang="x-none" smtClean="0"/>
-              <a:t>‹#›</a:t>
             </a:fld>
             <a:endParaRPr lang="x-none"/>
           </a:p>
         </p:txBody>
       </p:sp>
     </p:spTree>
-    <p:extLst>
-      <p:ext uri="{BB962C8B-B14F-4D97-AF65-F5344CB8AC3E}">
-        <p14:creationId xmlns:p14="http://schemas.microsoft.com/office/powerpoint/2010/main" val="1419938091"/>
-      </p:ext>
-    </p:extLst>
   </p:cSld>
   <p:clrMapOvr>
     <a:masterClrMapping/>
@@ -2129,13 +1899,7 @@
       </p:grpSpPr>
       <p:sp>
         <p:nvSpPr>
-          <p:cNvPr id="2" name="Title 1">
-            <a:extLst>
-              <a:ext uri="{FF2B5EF4-FFF2-40B4-BE49-F238E27FC236}">
-                <a16:creationId xmlns:a16="http://schemas.microsoft.com/office/drawing/2014/main" id="{CD4E31B6-B236-B0E2-5E86-4E38DD0A2938}"/>
-              </a:ext>
-            </a:extLst>
-          </p:cNvPr>
+          <p:cNvPr id="2" name="Title 1"/>
           <p:cNvSpPr>
             <a:spLocks noGrp="1"/>
           </p:cNvSpPr>
@@ -2152,18 +1916,13 @@
               <a:rPr lang="en-US"/>
               <a:t>Click to edit Master title style</a:t>
             </a:r>
+            <a:endParaRPr lang="en-US"/>
           </a:p>
         </p:txBody>
       </p:sp>
       <p:sp>
         <p:nvSpPr>
-          <p:cNvPr id="3" name="Content Placeholder 2">
-            <a:extLst>
-              <a:ext uri="{FF2B5EF4-FFF2-40B4-BE49-F238E27FC236}">
-                <a16:creationId xmlns:a16="http://schemas.microsoft.com/office/drawing/2014/main" id="{4EBBAE2F-C86B-6295-BF0C-8FA6535458AE}"/>
-              </a:ext>
-            </a:extLst>
-          </p:cNvPr>
+          <p:cNvPr id="3" name="Content Placeholder 2"/>
           <p:cNvSpPr>
             <a:spLocks noGrp="1"/>
           </p:cNvSpPr>
@@ -2186,6 +1945,7 @@
               <a:rPr lang="en-US"/>
               <a:t>Click to edit Master text styles</a:t>
             </a:r>
+            <a:endParaRPr lang="en-US"/>
           </a:p>
           <a:p>
             <a:pPr lvl="1"/>
@@ -2193,6 +1953,7 @@
               <a:rPr lang="en-US"/>
               <a:t>Second level</a:t>
             </a:r>
+            <a:endParaRPr lang="en-US"/>
           </a:p>
           <a:p>
             <a:pPr lvl="2"/>
@@ -2200,6 +1961,7 @@
               <a:rPr lang="en-US"/>
               <a:t>Third level</a:t>
             </a:r>
+            <a:endParaRPr lang="en-US"/>
           </a:p>
           <a:p>
             <a:pPr lvl="3"/>
@@ -2207,6 +1969,7 @@
               <a:rPr lang="en-US"/>
               <a:t>Fourth level</a:t>
             </a:r>
+            <a:endParaRPr lang="en-US"/>
           </a:p>
           <a:p>
             <a:pPr lvl="4"/>
@@ -2214,18 +1977,13 @@
               <a:rPr lang="en-US"/>
               <a:t>Fifth level</a:t>
             </a:r>
+            <a:endParaRPr lang="en-US"/>
           </a:p>
         </p:txBody>
       </p:sp>
       <p:sp>
         <p:nvSpPr>
-          <p:cNvPr id="4" name="Content Placeholder 3">
-            <a:extLst>
-              <a:ext uri="{FF2B5EF4-FFF2-40B4-BE49-F238E27FC236}">
-                <a16:creationId xmlns:a16="http://schemas.microsoft.com/office/drawing/2014/main" id="{F4D701D9-673D-9B55-FC50-1F099BC72F90}"/>
-              </a:ext>
-            </a:extLst>
-          </p:cNvPr>
+          <p:cNvPr id="4" name="Content Placeholder 3"/>
           <p:cNvSpPr>
             <a:spLocks noGrp="1"/>
           </p:cNvSpPr>
@@ -2248,6 +2006,7 @@
               <a:rPr lang="en-US"/>
               <a:t>Click to edit Master text styles</a:t>
             </a:r>
+            <a:endParaRPr lang="en-US"/>
           </a:p>
           <a:p>
             <a:pPr lvl="1"/>
@@ -2255,6 +2014,7 @@
               <a:rPr lang="en-US"/>
               <a:t>Second level</a:t>
             </a:r>
+            <a:endParaRPr lang="en-US"/>
           </a:p>
           <a:p>
             <a:pPr lvl="2"/>
@@ -2262,6 +2022,7 @@
               <a:rPr lang="en-US"/>
               <a:t>Third level</a:t>
             </a:r>
+            <a:endParaRPr lang="en-US"/>
           </a:p>
           <a:p>
             <a:pPr lvl="3"/>
@@ -2269,6 +2030,7 @@
               <a:rPr lang="en-US"/>
               <a:t>Fourth level</a:t>
             </a:r>
+            <a:endParaRPr lang="en-US"/>
           </a:p>
           <a:p>
             <a:pPr lvl="4"/>
@@ -2276,18 +2038,13 @@
               <a:rPr lang="en-US"/>
               <a:t>Fifth level</a:t>
             </a:r>
+            <a:endParaRPr lang="en-US"/>
           </a:p>
         </p:txBody>
       </p:sp>
       <p:sp>
         <p:nvSpPr>
-          <p:cNvPr id="5" name="Date Placeholder 4">
-            <a:extLst>
-              <a:ext uri="{FF2B5EF4-FFF2-40B4-BE49-F238E27FC236}">
-                <a16:creationId xmlns:a16="http://schemas.microsoft.com/office/drawing/2014/main" id="{C8332D0E-E9A2-663F-5C7E-3A3F6902E40D}"/>
-              </a:ext>
-            </a:extLst>
-          </p:cNvPr>
+          <p:cNvPr id="5" name="Date Placeholder 4"/>
           <p:cNvSpPr>
             <a:spLocks noGrp="1"/>
           </p:cNvSpPr>
@@ -2302,7 +2059,6 @@
           <a:p>
             <a:fld id="{F97F9DE9-0176-4232-90F5-7CEFD5A2742E}" type="datetimeFigureOut">
               <a:rPr lang="x-none" smtClean="0"/>
-              <a:t>1/20/2026</a:t>
             </a:fld>
             <a:endParaRPr lang="x-none"/>
           </a:p>
@@ -2310,13 +2066,7 @@
       </p:sp>
       <p:sp>
         <p:nvSpPr>
-          <p:cNvPr id="6" name="Footer Placeholder 5">
-            <a:extLst>
-              <a:ext uri="{FF2B5EF4-FFF2-40B4-BE49-F238E27FC236}">
-                <a16:creationId xmlns:a16="http://schemas.microsoft.com/office/drawing/2014/main" id="{AFF6C13D-F49E-A906-5EB1-0222FF4EA445}"/>
-              </a:ext>
-            </a:extLst>
-          </p:cNvPr>
+          <p:cNvPr id="6" name="Footer Placeholder 5"/>
           <p:cNvSpPr>
             <a:spLocks noGrp="1"/>
           </p:cNvSpPr>
@@ -2335,13 +2085,7 @@
       </p:sp>
       <p:sp>
         <p:nvSpPr>
-          <p:cNvPr id="7" name="Slide Number Placeholder 6">
-            <a:extLst>
-              <a:ext uri="{FF2B5EF4-FFF2-40B4-BE49-F238E27FC236}">
-                <a16:creationId xmlns:a16="http://schemas.microsoft.com/office/drawing/2014/main" id="{1A779C6A-BBAC-430B-065D-D51C36507FCA}"/>
-              </a:ext>
-            </a:extLst>
-          </p:cNvPr>
+          <p:cNvPr id="7" name="Slide Number Placeholder 6"/>
           <p:cNvSpPr>
             <a:spLocks noGrp="1"/>
           </p:cNvSpPr>
@@ -2356,18 +2100,12 @@
           <a:p>
             <a:fld id="{1EA25AC8-EF13-4E35-A362-B896E37E3AA9}" type="slidenum">
               <a:rPr lang="x-none" smtClean="0"/>
-              <a:t>‹#›</a:t>
             </a:fld>
             <a:endParaRPr lang="x-none"/>
           </a:p>
         </p:txBody>
       </p:sp>
     </p:spTree>
-    <p:extLst>
-      <p:ext uri="{BB962C8B-B14F-4D97-AF65-F5344CB8AC3E}">
-        <p14:creationId xmlns:p14="http://schemas.microsoft.com/office/powerpoint/2010/main" val="1303787079"/>
-      </p:ext>
-    </p:extLst>
   </p:cSld>
   <p:clrMapOvr>
     <a:masterClrMapping/>
@@ -2394,13 +2132,7 @@
       </p:grpSpPr>
       <p:sp>
         <p:nvSpPr>
-          <p:cNvPr id="2" name="Title 1">
-            <a:extLst>
-              <a:ext uri="{FF2B5EF4-FFF2-40B4-BE49-F238E27FC236}">
-                <a16:creationId xmlns:a16="http://schemas.microsoft.com/office/drawing/2014/main" id="{927E88CD-7A8B-D197-5CDD-9BB660426B36}"/>
-              </a:ext>
-            </a:extLst>
-          </p:cNvPr>
+          <p:cNvPr id="2" name="Title 1"/>
           <p:cNvSpPr>
             <a:spLocks noGrp="1"/>
           </p:cNvSpPr>
@@ -2422,18 +2154,13 @@
               <a:rPr lang="en-US"/>
               <a:t>Click to edit Master title style</a:t>
             </a:r>
+            <a:endParaRPr lang="en-US"/>
           </a:p>
         </p:txBody>
       </p:sp>
       <p:sp>
         <p:nvSpPr>
-          <p:cNvPr id="3" name="Text Placeholder 2">
-            <a:extLst>
-              <a:ext uri="{FF2B5EF4-FFF2-40B4-BE49-F238E27FC236}">
-                <a16:creationId xmlns:a16="http://schemas.microsoft.com/office/drawing/2014/main" id="{655CDF50-F98D-B758-AA7E-5617E908D287}"/>
-              </a:ext>
-            </a:extLst>
-          </p:cNvPr>
+          <p:cNvPr id="3" name="Text Placeholder 2"/>
           <p:cNvSpPr>
             <a:spLocks noGrp="1"/>
           </p:cNvSpPr>
@@ -2493,18 +2220,13 @@
               <a:rPr lang="en-US"/>
               <a:t>Click to edit Master text styles</a:t>
             </a:r>
+            <a:endParaRPr lang="en-US"/>
           </a:p>
         </p:txBody>
       </p:sp>
       <p:sp>
         <p:nvSpPr>
-          <p:cNvPr id="4" name="Content Placeholder 3">
-            <a:extLst>
-              <a:ext uri="{FF2B5EF4-FFF2-40B4-BE49-F238E27FC236}">
-                <a16:creationId xmlns:a16="http://schemas.microsoft.com/office/drawing/2014/main" id="{03AE61EE-9EC8-E34B-AAAA-213BBCD5A95F}"/>
-              </a:ext>
-            </a:extLst>
-          </p:cNvPr>
+          <p:cNvPr id="4" name="Content Placeholder 3"/>
           <p:cNvSpPr>
             <a:spLocks noGrp="1"/>
           </p:cNvSpPr>
@@ -2527,6 +2249,7 @@
               <a:rPr lang="en-US"/>
               <a:t>Click to edit Master text styles</a:t>
             </a:r>
+            <a:endParaRPr lang="en-US"/>
           </a:p>
           <a:p>
             <a:pPr lvl="1"/>
@@ -2534,6 +2257,7 @@
               <a:rPr lang="en-US"/>
               <a:t>Second level</a:t>
             </a:r>
+            <a:endParaRPr lang="en-US"/>
           </a:p>
           <a:p>
             <a:pPr lvl="2"/>
@@ -2541,6 +2265,7 @@
               <a:rPr lang="en-US"/>
               <a:t>Third level</a:t>
             </a:r>
+            <a:endParaRPr lang="en-US"/>
           </a:p>
           <a:p>
             <a:pPr lvl="3"/>
@@ -2548,6 +2273,7 @@
               <a:rPr lang="en-US"/>
               <a:t>Fourth level</a:t>
             </a:r>
+            <a:endParaRPr lang="en-US"/>
           </a:p>
           <a:p>
             <a:pPr lvl="4"/>
@@ -2555,18 +2281,13 @@
               <a:rPr lang="en-US"/>
               <a:t>Fifth level</a:t>
             </a:r>
+            <a:endParaRPr lang="en-US"/>
           </a:p>
         </p:txBody>
       </p:sp>
       <p:sp>
         <p:nvSpPr>
-          <p:cNvPr id="5" name="Text Placeholder 4">
-            <a:extLst>
-              <a:ext uri="{FF2B5EF4-FFF2-40B4-BE49-F238E27FC236}">
-                <a16:creationId xmlns:a16="http://schemas.microsoft.com/office/drawing/2014/main" id="{3D5F27C9-B0B2-F781-011B-B8E7BE4BFC98}"/>
-              </a:ext>
-            </a:extLst>
-          </p:cNvPr>
+          <p:cNvPr id="5" name="Text Placeholder 4"/>
           <p:cNvSpPr>
             <a:spLocks noGrp="1"/>
           </p:cNvSpPr>
@@ -2626,18 +2347,13 @@
               <a:rPr lang="en-US"/>
               <a:t>Click to edit Master text styles</a:t>
             </a:r>
+            <a:endParaRPr lang="en-US"/>
           </a:p>
         </p:txBody>
       </p:sp>
       <p:sp>
         <p:nvSpPr>
-          <p:cNvPr id="6" name="Content Placeholder 5">
-            <a:extLst>
-              <a:ext uri="{FF2B5EF4-FFF2-40B4-BE49-F238E27FC236}">
-                <a16:creationId xmlns:a16="http://schemas.microsoft.com/office/drawing/2014/main" id="{C78754A0-2FFB-94BB-C87D-AD4A75F882A4}"/>
-              </a:ext>
-            </a:extLst>
-          </p:cNvPr>
+          <p:cNvPr id="6" name="Content Placeholder 5"/>
           <p:cNvSpPr>
             <a:spLocks noGrp="1"/>
           </p:cNvSpPr>
@@ -2660,6 +2376,7 @@
               <a:rPr lang="en-US"/>
               <a:t>Click to edit Master text styles</a:t>
             </a:r>
+            <a:endParaRPr lang="en-US"/>
           </a:p>
           <a:p>
             <a:pPr lvl="1"/>
@@ -2667,6 +2384,7 @@
               <a:rPr lang="en-US"/>
               <a:t>Second level</a:t>
             </a:r>
+            <a:endParaRPr lang="en-US"/>
           </a:p>
           <a:p>
             <a:pPr lvl="2"/>
@@ -2674,6 +2392,7 @@
               <a:rPr lang="en-US"/>
               <a:t>Third level</a:t>
             </a:r>
+            <a:endParaRPr lang="en-US"/>
           </a:p>
           <a:p>
             <a:pPr lvl="3"/>
@@ -2681,6 +2400,7 @@
               <a:rPr lang="en-US"/>
               <a:t>Fourth level</a:t>
             </a:r>
+            <a:endParaRPr lang="en-US"/>
           </a:p>
           <a:p>
             <a:pPr lvl="4"/>
@@ -2688,18 +2408,13 @@
               <a:rPr lang="en-US"/>
               <a:t>Fifth level</a:t>
             </a:r>
+            <a:endParaRPr lang="en-US"/>
           </a:p>
         </p:txBody>
       </p:sp>
       <p:sp>
         <p:nvSpPr>
-          <p:cNvPr id="7" name="Date Placeholder 6">
-            <a:extLst>
-              <a:ext uri="{FF2B5EF4-FFF2-40B4-BE49-F238E27FC236}">
-                <a16:creationId xmlns:a16="http://schemas.microsoft.com/office/drawing/2014/main" id="{AC2900C6-DCFC-1760-8D83-3AD2466E8AB7}"/>
-              </a:ext>
-            </a:extLst>
-          </p:cNvPr>
+          <p:cNvPr id="7" name="Date Placeholder 6"/>
           <p:cNvSpPr>
             <a:spLocks noGrp="1"/>
           </p:cNvSpPr>
@@ -2714,7 +2429,6 @@
           <a:p>
             <a:fld id="{F97F9DE9-0176-4232-90F5-7CEFD5A2742E}" type="datetimeFigureOut">
               <a:rPr lang="x-none" smtClean="0"/>
-              <a:t>1/20/2026</a:t>
             </a:fld>
             <a:endParaRPr lang="x-none"/>
           </a:p>
@@ -2722,13 +2436,7 @@
       </p:sp>
       <p:sp>
         <p:nvSpPr>
-          <p:cNvPr id="8" name="Footer Placeholder 7">
-            <a:extLst>
-              <a:ext uri="{FF2B5EF4-FFF2-40B4-BE49-F238E27FC236}">
-                <a16:creationId xmlns:a16="http://schemas.microsoft.com/office/drawing/2014/main" id="{17991F69-2B20-AA3D-AA6D-3C5DB859A989}"/>
-              </a:ext>
-            </a:extLst>
-          </p:cNvPr>
+          <p:cNvPr id="8" name="Footer Placeholder 7"/>
           <p:cNvSpPr>
             <a:spLocks noGrp="1"/>
           </p:cNvSpPr>
@@ -2747,13 +2455,7 @@
       </p:sp>
       <p:sp>
         <p:nvSpPr>
-          <p:cNvPr id="9" name="Slide Number Placeholder 8">
-            <a:extLst>
-              <a:ext uri="{FF2B5EF4-FFF2-40B4-BE49-F238E27FC236}">
-                <a16:creationId xmlns:a16="http://schemas.microsoft.com/office/drawing/2014/main" id="{D45122E3-AEFC-8232-B6D9-3657CC0975BA}"/>
-              </a:ext>
-            </a:extLst>
-          </p:cNvPr>
+          <p:cNvPr id="9" name="Slide Number Placeholder 8"/>
           <p:cNvSpPr>
             <a:spLocks noGrp="1"/>
           </p:cNvSpPr>
@@ -2768,18 +2470,12 @@
           <a:p>
             <a:fld id="{1EA25AC8-EF13-4E35-A362-B896E37E3AA9}" type="slidenum">
               <a:rPr lang="x-none" smtClean="0"/>
-              <a:t>‹#›</a:t>
             </a:fld>
             <a:endParaRPr lang="x-none"/>
           </a:p>
         </p:txBody>
       </p:sp>
     </p:spTree>
-    <p:extLst>
-      <p:ext uri="{BB962C8B-B14F-4D97-AF65-F5344CB8AC3E}">
-        <p14:creationId xmlns:p14="http://schemas.microsoft.com/office/powerpoint/2010/main" val="2051615552"/>
-      </p:ext>
-    </p:extLst>
   </p:cSld>
   <p:clrMapOvr>
     <a:masterClrMapping/>
@@ -2806,13 +2502,7 @@
       </p:grpSpPr>
       <p:sp>
         <p:nvSpPr>
-          <p:cNvPr id="2" name="Title 1">
-            <a:extLst>
-              <a:ext uri="{FF2B5EF4-FFF2-40B4-BE49-F238E27FC236}">
-                <a16:creationId xmlns:a16="http://schemas.microsoft.com/office/drawing/2014/main" id="{89F316F9-A589-FCE4-30B1-374A31BFDBE5}"/>
-              </a:ext>
-            </a:extLst>
-          </p:cNvPr>
+          <p:cNvPr id="2" name="Title 1"/>
           <p:cNvSpPr>
             <a:spLocks noGrp="1"/>
           </p:cNvSpPr>
@@ -2829,18 +2519,13 @@
               <a:rPr lang="en-US"/>
               <a:t>Click to edit Master title style</a:t>
             </a:r>
+            <a:endParaRPr lang="en-US"/>
           </a:p>
         </p:txBody>
       </p:sp>
       <p:sp>
         <p:nvSpPr>
-          <p:cNvPr id="3" name="Date Placeholder 2">
-            <a:extLst>
-              <a:ext uri="{FF2B5EF4-FFF2-40B4-BE49-F238E27FC236}">
-                <a16:creationId xmlns:a16="http://schemas.microsoft.com/office/drawing/2014/main" id="{11B24348-39E0-417F-0D31-1AE59269963B}"/>
-              </a:ext>
-            </a:extLst>
-          </p:cNvPr>
+          <p:cNvPr id="3" name="Date Placeholder 2"/>
           <p:cNvSpPr>
             <a:spLocks noGrp="1"/>
           </p:cNvSpPr>
@@ -2855,7 +2540,6 @@
           <a:p>
             <a:fld id="{F97F9DE9-0176-4232-90F5-7CEFD5A2742E}" type="datetimeFigureOut">
               <a:rPr lang="x-none" smtClean="0"/>
-              <a:t>1/20/2026</a:t>
             </a:fld>
             <a:endParaRPr lang="x-none"/>
           </a:p>
@@ -2863,13 +2547,7 @@
       </p:sp>
       <p:sp>
         <p:nvSpPr>
-          <p:cNvPr id="4" name="Footer Placeholder 3">
-            <a:extLst>
-              <a:ext uri="{FF2B5EF4-FFF2-40B4-BE49-F238E27FC236}">
-                <a16:creationId xmlns:a16="http://schemas.microsoft.com/office/drawing/2014/main" id="{F91EFBF0-D701-B2C4-C6F1-3A7A4F6EB078}"/>
-              </a:ext>
-            </a:extLst>
-          </p:cNvPr>
+          <p:cNvPr id="4" name="Footer Placeholder 3"/>
           <p:cNvSpPr>
             <a:spLocks noGrp="1"/>
           </p:cNvSpPr>
@@ -2888,13 +2566,7 @@
       </p:sp>
       <p:sp>
         <p:nvSpPr>
-          <p:cNvPr id="5" name="Slide Number Placeholder 4">
-            <a:extLst>
-              <a:ext uri="{FF2B5EF4-FFF2-40B4-BE49-F238E27FC236}">
-                <a16:creationId xmlns:a16="http://schemas.microsoft.com/office/drawing/2014/main" id="{E2148DC2-D69B-5C1F-6C2E-6BCB32A50705}"/>
-              </a:ext>
-            </a:extLst>
-          </p:cNvPr>
+          <p:cNvPr id="5" name="Slide Number Placeholder 4"/>
           <p:cNvSpPr>
             <a:spLocks noGrp="1"/>
           </p:cNvSpPr>
@@ -2909,18 +2581,12 @@
           <a:p>
             <a:fld id="{1EA25AC8-EF13-4E35-A362-B896E37E3AA9}" type="slidenum">
               <a:rPr lang="x-none" smtClean="0"/>
-              <a:t>‹#›</a:t>
             </a:fld>
             <a:endParaRPr lang="x-none"/>
           </a:p>
         </p:txBody>
       </p:sp>
     </p:spTree>
-    <p:extLst>
-      <p:ext uri="{BB962C8B-B14F-4D97-AF65-F5344CB8AC3E}">
-        <p14:creationId xmlns:p14="http://schemas.microsoft.com/office/powerpoint/2010/main" val="4108416090"/>
-      </p:ext>
-    </p:extLst>
   </p:cSld>
   <p:clrMapOvr>
     <a:masterClrMapping/>
@@ -2947,13 +2613,7 @@
       </p:grpSpPr>
       <p:sp>
         <p:nvSpPr>
-          <p:cNvPr id="2" name="Date Placeholder 1">
-            <a:extLst>
-              <a:ext uri="{FF2B5EF4-FFF2-40B4-BE49-F238E27FC236}">
-                <a16:creationId xmlns:a16="http://schemas.microsoft.com/office/drawing/2014/main" id="{9C714498-81E9-164A-F668-0B8C4FE042F6}"/>
-              </a:ext>
-            </a:extLst>
-          </p:cNvPr>
+          <p:cNvPr id="2" name="Date Placeholder 1"/>
           <p:cNvSpPr>
             <a:spLocks noGrp="1"/>
           </p:cNvSpPr>
@@ -2968,7 +2628,6 @@
           <a:p>
             <a:fld id="{F97F9DE9-0176-4232-90F5-7CEFD5A2742E}" type="datetimeFigureOut">
               <a:rPr lang="x-none" smtClean="0"/>
-              <a:t>1/20/2026</a:t>
             </a:fld>
             <a:endParaRPr lang="x-none"/>
           </a:p>
@@ -2976,13 +2635,7 @@
       </p:sp>
       <p:sp>
         <p:nvSpPr>
-          <p:cNvPr id="3" name="Footer Placeholder 2">
-            <a:extLst>
-              <a:ext uri="{FF2B5EF4-FFF2-40B4-BE49-F238E27FC236}">
-                <a16:creationId xmlns:a16="http://schemas.microsoft.com/office/drawing/2014/main" id="{C2052A3D-4770-6C4C-C97C-14DE252FC23B}"/>
-              </a:ext>
-            </a:extLst>
-          </p:cNvPr>
+          <p:cNvPr id="3" name="Footer Placeholder 2"/>
           <p:cNvSpPr>
             <a:spLocks noGrp="1"/>
           </p:cNvSpPr>
@@ -3001,13 +2654,7 @@
       </p:sp>
       <p:sp>
         <p:nvSpPr>
-          <p:cNvPr id="4" name="Slide Number Placeholder 3">
-            <a:extLst>
-              <a:ext uri="{FF2B5EF4-FFF2-40B4-BE49-F238E27FC236}">
-                <a16:creationId xmlns:a16="http://schemas.microsoft.com/office/drawing/2014/main" id="{363459E5-85AE-7428-E08A-7E2047C8CD09}"/>
-              </a:ext>
-            </a:extLst>
-          </p:cNvPr>
+          <p:cNvPr id="4" name="Slide Number Placeholder 3"/>
           <p:cNvSpPr>
             <a:spLocks noGrp="1"/>
           </p:cNvSpPr>
@@ -3022,18 +2669,12 @@
           <a:p>
             <a:fld id="{1EA25AC8-EF13-4E35-A362-B896E37E3AA9}" type="slidenum">
               <a:rPr lang="x-none" smtClean="0"/>
-              <a:t>‹#›</a:t>
             </a:fld>
             <a:endParaRPr lang="x-none"/>
           </a:p>
         </p:txBody>
       </p:sp>
     </p:spTree>
-    <p:extLst>
-      <p:ext uri="{BB962C8B-B14F-4D97-AF65-F5344CB8AC3E}">
-        <p14:creationId xmlns:p14="http://schemas.microsoft.com/office/powerpoint/2010/main" val="2476192150"/>
-      </p:ext>
-    </p:extLst>
   </p:cSld>
   <p:clrMapOvr>
     <a:masterClrMapping/>
@@ -3060,13 +2701,7 @@
       </p:grpSpPr>
       <p:sp>
         <p:nvSpPr>
-          <p:cNvPr id="2" name="Title 1">
-            <a:extLst>
-              <a:ext uri="{FF2B5EF4-FFF2-40B4-BE49-F238E27FC236}">
-                <a16:creationId xmlns:a16="http://schemas.microsoft.com/office/drawing/2014/main" id="{B9D94331-4504-FD28-178A-B2B3DD22C8B1}"/>
-              </a:ext>
-            </a:extLst>
-          </p:cNvPr>
+          <p:cNvPr id="2" name="Title 1"/>
           <p:cNvSpPr>
             <a:spLocks noGrp="1"/>
           </p:cNvSpPr>
@@ -3092,18 +2727,13 @@
               <a:rPr lang="en-US"/>
               <a:t>Click to edit Master title style</a:t>
             </a:r>
+            <a:endParaRPr lang="en-US"/>
           </a:p>
         </p:txBody>
       </p:sp>
       <p:sp>
         <p:nvSpPr>
-          <p:cNvPr id="3" name="Content Placeholder 2">
-            <a:extLst>
-              <a:ext uri="{FF2B5EF4-FFF2-40B4-BE49-F238E27FC236}">
-                <a16:creationId xmlns:a16="http://schemas.microsoft.com/office/drawing/2014/main" id="{968E0E4B-EBA3-3E5D-4559-7245093B7E11}"/>
-              </a:ext>
-            </a:extLst>
-          </p:cNvPr>
+          <p:cNvPr id="3" name="Content Placeholder 2"/>
           <p:cNvSpPr>
             <a:spLocks noGrp="1"/>
           </p:cNvSpPr>
@@ -3154,6 +2784,7 @@
               <a:rPr lang="en-US"/>
               <a:t>Click to edit Master text styles</a:t>
             </a:r>
+            <a:endParaRPr lang="en-US"/>
           </a:p>
           <a:p>
             <a:pPr lvl="1"/>
@@ -3161,6 +2792,7 @@
               <a:rPr lang="en-US"/>
               <a:t>Second level</a:t>
             </a:r>
+            <a:endParaRPr lang="en-US"/>
           </a:p>
           <a:p>
             <a:pPr lvl="2"/>
@@ -3168,6 +2800,7 @@
               <a:rPr lang="en-US"/>
               <a:t>Third level</a:t>
             </a:r>
+            <a:endParaRPr lang="en-US"/>
           </a:p>
           <a:p>
             <a:pPr lvl="3"/>
@@ -3175,6 +2808,7 @@
               <a:rPr lang="en-US"/>
               <a:t>Fourth level</a:t>
             </a:r>
+            <a:endParaRPr lang="en-US"/>
           </a:p>
           <a:p>
             <a:pPr lvl="4"/>
@@ -3182,18 +2816,13 @@
               <a:rPr lang="en-US"/>
               <a:t>Fifth level</a:t>
             </a:r>
+            <a:endParaRPr lang="en-US"/>
           </a:p>
         </p:txBody>
       </p:sp>
       <p:sp>
         <p:nvSpPr>
-          <p:cNvPr id="4" name="Text Placeholder 3">
-            <a:extLst>
-              <a:ext uri="{FF2B5EF4-FFF2-40B4-BE49-F238E27FC236}">
-                <a16:creationId xmlns:a16="http://schemas.microsoft.com/office/drawing/2014/main" id="{2C8370AE-5128-966B-6815-57BD65585D01}"/>
-              </a:ext>
-            </a:extLst>
-          </p:cNvPr>
+          <p:cNvPr id="4" name="Text Placeholder 3"/>
           <p:cNvSpPr>
             <a:spLocks noGrp="1"/>
           </p:cNvSpPr>
@@ -3253,18 +2882,13 @@
               <a:rPr lang="en-US"/>
               <a:t>Click to edit Master text styles</a:t>
             </a:r>
+            <a:endParaRPr lang="en-US"/>
           </a:p>
         </p:txBody>
       </p:sp>
       <p:sp>
         <p:nvSpPr>
-          <p:cNvPr id="5" name="Date Placeholder 4">
-            <a:extLst>
-              <a:ext uri="{FF2B5EF4-FFF2-40B4-BE49-F238E27FC236}">
-                <a16:creationId xmlns:a16="http://schemas.microsoft.com/office/drawing/2014/main" id="{D559513A-4DE2-4792-DB09-C3DCB6B8323A}"/>
-              </a:ext>
-            </a:extLst>
-          </p:cNvPr>
+          <p:cNvPr id="5" name="Date Placeholder 4"/>
           <p:cNvSpPr>
             <a:spLocks noGrp="1"/>
           </p:cNvSpPr>
@@ -3279,7 +2903,6 @@
           <a:p>
             <a:fld id="{F97F9DE9-0176-4232-90F5-7CEFD5A2742E}" type="datetimeFigureOut">
               <a:rPr lang="x-none" smtClean="0"/>
-              <a:t>1/20/2026</a:t>
             </a:fld>
             <a:endParaRPr lang="x-none"/>
           </a:p>
@@ -3287,13 +2910,7 @@
       </p:sp>
       <p:sp>
         <p:nvSpPr>
-          <p:cNvPr id="6" name="Footer Placeholder 5">
-            <a:extLst>
-              <a:ext uri="{FF2B5EF4-FFF2-40B4-BE49-F238E27FC236}">
-                <a16:creationId xmlns:a16="http://schemas.microsoft.com/office/drawing/2014/main" id="{C2B2FDCB-A6F5-34C3-AFE9-B29C7F580C3E}"/>
-              </a:ext>
-            </a:extLst>
-          </p:cNvPr>
+          <p:cNvPr id="6" name="Footer Placeholder 5"/>
           <p:cNvSpPr>
             <a:spLocks noGrp="1"/>
           </p:cNvSpPr>
@@ -3312,13 +2929,7 @@
       </p:sp>
       <p:sp>
         <p:nvSpPr>
-          <p:cNvPr id="7" name="Slide Number Placeholder 6">
-            <a:extLst>
-              <a:ext uri="{FF2B5EF4-FFF2-40B4-BE49-F238E27FC236}">
-                <a16:creationId xmlns:a16="http://schemas.microsoft.com/office/drawing/2014/main" id="{F67B6E34-B067-02C1-A565-95DF676DDA00}"/>
-              </a:ext>
-            </a:extLst>
-          </p:cNvPr>
+          <p:cNvPr id="7" name="Slide Number Placeholder 6"/>
           <p:cNvSpPr>
             <a:spLocks noGrp="1"/>
           </p:cNvSpPr>
@@ -3333,18 +2944,12 @@
           <a:p>
             <a:fld id="{1EA25AC8-EF13-4E35-A362-B896E37E3AA9}" type="slidenum">
               <a:rPr lang="x-none" smtClean="0"/>
-              <a:t>‹#›</a:t>
             </a:fld>
             <a:endParaRPr lang="x-none"/>
           </a:p>
         </p:txBody>
       </p:sp>
     </p:spTree>
-    <p:extLst>
-      <p:ext uri="{BB962C8B-B14F-4D97-AF65-F5344CB8AC3E}">
-        <p14:creationId xmlns:p14="http://schemas.microsoft.com/office/powerpoint/2010/main" val="4001772607"/>
-      </p:ext>
-    </p:extLst>
   </p:cSld>
   <p:clrMapOvr>
     <a:masterClrMapping/>
@@ -3371,13 +2976,7 @@
       </p:grpSpPr>
       <p:sp>
         <p:nvSpPr>
-          <p:cNvPr id="2" name="Title 1">
-            <a:extLst>
-              <a:ext uri="{FF2B5EF4-FFF2-40B4-BE49-F238E27FC236}">
-                <a16:creationId xmlns:a16="http://schemas.microsoft.com/office/drawing/2014/main" id="{8EF32A1E-4822-28E3-3C38-AA33DD68605C}"/>
-              </a:ext>
-            </a:extLst>
-          </p:cNvPr>
+          <p:cNvPr id="2" name="Title 1"/>
           <p:cNvSpPr>
             <a:spLocks noGrp="1"/>
           </p:cNvSpPr>
@@ -3403,18 +3002,13 @@
               <a:rPr lang="en-US"/>
               <a:t>Click to edit Master title style</a:t>
             </a:r>
+            <a:endParaRPr lang="en-US"/>
           </a:p>
         </p:txBody>
       </p:sp>
       <p:sp>
         <p:nvSpPr>
-          <p:cNvPr id="3" name="Picture Placeholder 2">
-            <a:extLst>
-              <a:ext uri="{FF2B5EF4-FFF2-40B4-BE49-F238E27FC236}">
-                <a16:creationId xmlns:a16="http://schemas.microsoft.com/office/drawing/2014/main" id="{13D929F0-3690-FB0C-E242-FA4ECD63BA78}"/>
-              </a:ext>
-            </a:extLst>
-          </p:cNvPr>
+          <p:cNvPr id="3" name="Picture Placeholder 2"/>
           <p:cNvSpPr>
             <a:spLocks noGrp="1"/>
           </p:cNvSpPr>
@@ -3475,13 +3069,7 @@
       </p:sp>
       <p:sp>
         <p:nvSpPr>
-          <p:cNvPr id="4" name="Text Placeholder 3">
-            <a:extLst>
-              <a:ext uri="{FF2B5EF4-FFF2-40B4-BE49-F238E27FC236}">
-                <a16:creationId xmlns:a16="http://schemas.microsoft.com/office/drawing/2014/main" id="{3D0AC275-093B-3A15-6877-B6AA4E2CE154}"/>
-              </a:ext>
-            </a:extLst>
-          </p:cNvPr>
+          <p:cNvPr id="4" name="Text Placeholder 3"/>
           <p:cNvSpPr>
             <a:spLocks noGrp="1"/>
           </p:cNvSpPr>
@@ -3541,18 +3129,13 @@
               <a:rPr lang="en-US"/>
               <a:t>Click to edit Master text styles</a:t>
             </a:r>
+            <a:endParaRPr lang="en-US"/>
           </a:p>
         </p:txBody>
       </p:sp>
       <p:sp>
         <p:nvSpPr>
-          <p:cNvPr id="5" name="Date Placeholder 4">
-            <a:extLst>
-              <a:ext uri="{FF2B5EF4-FFF2-40B4-BE49-F238E27FC236}">
-                <a16:creationId xmlns:a16="http://schemas.microsoft.com/office/drawing/2014/main" id="{B5E5C40D-A3E4-5C51-C3C3-A7572019BFB2}"/>
-              </a:ext>
-            </a:extLst>
-          </p:cNvPr>
+          <p:cNvPr id="5" name="Date Placeholder 4"/>
           <p:cNvSpPr>
             <a:spLocks noGrp="1"/>
           </p:cNvSpPr>
@@ -3567,7 +3150,6 @@
           <a:p>
             <a:fld id="{F97F9DE9-0176-4232-90F5-7CEFD5A2742E}" type="datetimeFigureOut">
               <a:rPr lang="x-none" smtClean="0"/>
-              <a:t>1/20/2026</a:t>
             </a:fld>
             <a:endParaRPr lang="x-none"/>
           </a:p>
@@ -3575,13 +3157,7 @@
       </p:sp>
       <p:sp>
         <p:nvSpPr>
-          <p:cNvPr id="6" name="Footer Placeholder 5">
-            <a:extLst>
-              <a:ext uri="{FF2B5EF4-FFF2-40B4-BE49-F238E27FC236}">
-                <a16:creationId xmlns:a16="http://schemas.microsoft.com/office/drawing/2014/main" id="{B99220A8-4C59-77B6-8A73-3C5CF8BE5525}"/>
-              </a:ext>
-            </a:extLst>
-          </p:cNvPr>
+          <p:cNvPr id="6" name="Footer Placeholder 5"/>
           <p:cNvSpPr>
             <a:spLocks noGrp="1"/>
           </p:cNvSpPr>
@@ -3600,13 +3176,7 @@
       </p:sp>
       <p:sp>
         <p:nvSpPr>
-          <p:cNvPr id="7" name="Slide Number Placeholder 6">
-            <a:extLst>
-              <a:ext uri="{FF2B5EF4-FFF2-40B4-BE49-F238E27FC236}">
-                <a16:creationId xmlns:a16="http://schemas.microsoft.com/office/drawing/2014/main" id="{3689688D-85BA-0E8F-9B17-FD3A15AC14E8}"/>
-              </a:ext>
-            </a:extLst>
-          </p:cNvPr>
+          <p:cNvPr id="7" name="Slide Number Placeholder 6"/>
           <p:cNvSpPr>
             <a:spLocks noGrp="1"/>
           </p:cNvSpPr>
@@ -3621,18 +3191,12 @@
           <a:p>
             <a:fld id="{1EA25AC8-EF13-4E35-A362-B896E37E3AA9}" type="slidenum">
               <a:rPr lang="x-none" smtClean="0"/>
-              <a:t>‹#›</a:t>
             </a:fld>
             <a:endParaRPr lang="x-none"/>
           </a:p>
         </p:txBody>
       </p:sp>
     </p:spTree>
-    <p:extLst>
-      <p:ext uri="{BB962C8B-B14F-4D97-AF65-F5344CB8AC3E}">
-        <p14:creationId xmlns:p14="http://schemas.microsoft.com/office/powerpoint/2010/main" val="2011670601"/>
-      </p:ext>
-    </p:extLst>
   </p:cSld>
   <p:clrMapOvr>
     <a:masterClrMapping/>
@@ -3664,13 +3228,7 @@
       </p:grpSpPr>
       <p:sp>
         <p:nvSpPr>
-          <p:cNvPr id="2" name="Title Placeholder 1">
-            <a:extLst>
-              <a:ext uri="{FF2B5EF4-FFF2-40B4-BE49-F238E27FC236}">
-                <a16:creationId xmlns:a16="http://schemas.microsoft.com/office/drawing/2014/main" id="{F8264BCA-56BC-B6B3-7E3C-332D9C2C2E6A}"/>
-              </a:ext>
-            </a:extLst>
-          </p:cNvPr>
+          <p:cNvPr id="2" name="Title Placeholder 1"/>
           <p:cNvSpPr>
             <a:spLocks noGrp="1"/>
           </p:cNvSpPr>
@@ -3697,18 +3255,13 @@
               <a:rPr lang="en-US"/>
               <a:t>Click to edit Master title style</a:t>
             </a:r>
+            <a:endParaRPr lang="en-US"/>
           </a:p>
         </p:txBody>
       </p:sp>
       <p:sp>
         <p:nvSpPr>
-          <p:cNvPr id="3" name="Text Placeholder 2">
-            <a:extLst>
-              <a:ext uri="{FF2B5EF4-FFF2-40B4-BE49-F238E27FC236}">
-                <a16:creationId xmlns:a16="http://schemas.microsoft.com/office/drawing/2014/main" id="{884ECC2A-4F98-18E0-5501-6695EC4862A7}"/>
-              </a:ext>
-            </a:extLst>
-          </p:cNvPr>
+          <p:cNvPr id="3" name="Text Placeholder 2"/>
           <p:cNvSpPr>
             <a:spLocks noGrp="1"/>
           </p:cNvSpPr>
@@ -3736,6 +3289,7 @@
               <a:rPr lang="en-US"/>
               <a:t>Click to edit Master text styles</a:t>
             </a:r>
+            <a:endParaRPr lang="en-US"/>
           </a:p>
           <a:p>
             <a:pPr lvl="1"/>
@@ -3743,6 +3297,7 @@
               <a:rPr lang="en-US"/>
               <a:t>Second level</a:t>
             </a:r>
+            <a:endParaRPr lang="en-US"/>
           </a:p>
           <a:p>
             <a:pPr lvl="2"/>
@@ -3750,6 +3305,7 @@
               <a:rPr lang="en-US"/>
               <a:t>Third level</a:t>
             </a:r>
+            <a:endParaRPr lang="en-US"/>
           </a:p>
           <a:p>
             <a:pPr lvl="3"/>
@@ -3757,6 +3313,7 @@
               <a:rPr lang="en-US"/>
               <a:t>Fourth level</a:t>
             </a:r>
+            <a:endParaRPr lang="en-US"/>
           </a:p>
           <a:p>
             <a:pPr lvl="4"/>
@@ -3764,18 +3321,13 @@
               <a:rPr lang="en-US"/>
               <a:t>Fifth level</a:t>
             </a:r>
+            <a:endParaRPr lang="en-US"/>
           </a:p>
         </p:txBody>
       </p:sp>
       <p:sp>
         <p:nvSpPr>
-          <p:cNvPr id="4" name="Date Placeholder 3">
-            <a:extLst>
-              <a:ext uri="{FF2B5EF4-FFF2-40B4-BE49-F238E27FC236}">
-                <a16:creationId xmlns:a16="http://schemas.microsoft.com/office/drawing/2014/main" id="{2C25B1CB-5437-E52E-8812-DD2085D2B46F}"/>
-              </a:ext>
-            </a:extLst>
-          </p:cNvPr>
+          <p:cNvPr id="4" name="Date Placeholder 3"/>
           <p:cNvSpPr>
             <a:spLocks noGrp="1"/>
           </p:cNvSpPr>
@@ -3808,7 +3360,6 @@
           <a:p>
             <a:fld id="{F97F9DE9-0176-4232-90F5-7CEFD5A2742E}" type="datetimeFigureOut">
               <a:rPr lang="x-none" smtClean="0"/>
-              <a:t>1/20/2026</a:t>
             </a:fld>
             <a:endParaRPr lang="x-none"/>
           </a:p>
@@ -3816,13 +3367,7 @@
       </p:sp>
       <p:sp>
         <p:nvSpPr>
-          <p:cNvPr id="5" name="Footer Placeholder 4">
-            <a:extLst>
-              <a:ext uri="{FF2B5EF4-FFF2-40B4-BE49-F238E27FC236}">
-                <a16:creationId xmlns:a16="http://schemas.microsoft.com/office/drawing/2014/main" id="{823BB8E4-C411-A2DF-1C29-B4EF43AA13B2}"/>
-              </a:ext>
-            </a:extLst>
-          </p:cNvPr>
+          <p:cNvPr id="5" name="Footer Placeholder 4"/>
           <p:cNvSpPr>
             <a:spLocks noGrp="1"/>
           </p:cNvSpPr>
@@ -3859,13 +3404,7 @@
       </p:sp>
       <p:sp>
         <p:nvSpPr>
-          <p:cNvPr id="6" name="Slide Number Placeholder 5">
-            <a:extLst>
-              <a:ext uri="{FF2B5EF4-FFF2-40B4-BE49-F238E27FC236}">
-                <a16:creationId xmlns:a16="http://schemas.microsoft.com/office/drawing/2014/main" id="{C16C8E34-01BD-DCE5-6D1B-8BD868DA86C3}"/>
-              </a:ext>
-            </a:extLst>
-          </p:cNvPr>
+          <p:cNvPr id="6" name="Slide Number Placeholder 5"/>
           <p:cNvSpPr>
             <a:spLocks noGrp="1"/>
           </p:cNvSpPr>
@@ -3898,33 +3437,27 @@
           <a:p>
             <a:fld id="{1EA25AC8-EF13-4E35-A362-B896E37E3AA9}" type="slidenum">
               <a:rPr lang="x-none" smtClean="0"/>
-              <a:t>‹#›</a:t>
             </a:fld>
             <a:endParaRPr lang="x-none"/>
           </a:p>
         </p:txBody>
       </p:sp>
     </p:spTree>
-    <p:extLst>
-      <p:ext uri="{BB962C8B-B14F-4D97-AF65-F5344CB8AC3E}">
-        <p14:creationId xmlns:p14="http://schemas.microsoft.com/office/powerpoint/2010/main" val="362923159"/>
-      </p:ext>
-    </p:extLst>
   </p:cSld>
   <p:clrMap bg1="lt1" tx1="dk1" bg2="lt2" tx2="dk2" accent1="accent1" accent2="accent2" accent3="accent3" accent4="accent4" accent5="accent5" accent6="accent6" hlink="hlink" folHlink="folHlink"/>
   <p:sldLayoutIdLst>
-    <p:sldLayoutId id="2147483674" r:id="rId1"/>
-    <p:sldLayoutId id="2147483675" r:id="rId2"/>
-    <p:sldLayoutId id="2147483676" r:id="rId3"/>
-    <p:sldLayoutId id="2147483677" r:id="rId4"/>
-    <p:sldLayoutId id="2147483678" r:id="rId5"/>
-    <p:sldLayoutId id="2147483679" r:id="rId6"/>
-    <p:sldLayoutId id="2147483680" r:id="rId7"/>
-    <p:sldLayoutId id="2147483681" r:id="rId8"/>
-    <p:sldLayoutId id="2147483682" r:id="rId9"/>
-    <p:sldLayoutId id="2147483683" r:id="rId10"/>
-    <p:sldLayoutId id="2147483684" r:id="rId11"/>
-    <p:sldLayoutId id="2147483685" r:id="rId12"/>
+    <p:sldLayoutId id="2147483649" r:id="rId1"/>
+    <p:sldLayoutId id="2147483650" r:id="rId2"/>
+    <p:sldLayoutId id="2147483651" r:id="rId3"/>
+    <p:sldLayoutId id="2147483652" r:id="rId4"/>
+    <p:sldLayoutId id="2147483653" r:id="rId5"/>
+    <p:sldLayoutId id="2147483654" r:id="rId6"/>
+    <p:sldLayoutId id="2147483655" r:id="rId7"/>
+    <p:sldLayoutId id="2147483656" r:id="rId8"/>
+    <p:sldLayoutId id="2147483657" r:id="rId9"/>
+    <p:sldLayoutId id="2147483658" r:id="rId10"/>
+    <p:sldLayoutId id="2147483659" r:id="rId11"/>
+    <p:sldLayoutId id="2147483660" r:id="rId12"/>
   </p:sldLayoutIdLst>
   <p:txStyles>
     <p:titleStyle>
@@ -4228,20 +3761,14 @@
       </p:grpSpPr>
       <p:pic>
         <p:nvPicPr>
-          <p:cNvPr id="2" name="Picture 1">
-            <a:extLst>
-              <a:ext uri="{FF2B5EF4-FFF2-40B4-BE49-F238E27FC236}">
-                <a16:creationId xmlns:a16="http://schemas.microsoft.com/office/drawing/2014/main" id="{53EB544C-0AF5-4D51-AAC5-0192D6EABC2E}"/>
-              </a:ext>
-            </a:extLst>
-          </p:cNvPr>
+          <p:cNvPr id="2" name="Picture 1"/>
           <p:cNvPicPr>
             <a:picLocks noChangeAspect="1"/>
           </p:cNvPicPr>
           <p:nvPr/>
         </p:nvPicPr>
         <p:blipFill>
-          <a:blip r:embed="rId2">
+          <a:blip r:embed="rId1">
             <a:extLst>
               <a:ext uri="{28A0092B-C50C-407E-A947-70E740481C1C}">
                 <a14:useLocalDpi xmlns:a14="http://schemas.microsoft.com/office/drawing/2010/main" val="0"/>
@@ -4264,13 +3791,7 @@
       </p:pic>
       <p:sp>
         <p:nvSpPr>
-          <p:cNvPr id="4" name="TextBox 3">
-            <a:extLst>
-              <a:ext uri="{FF2B5EF4-FFF2-40B4-BE49-F238E27FC236}">
-                <a16:creationId xmlns:a16="http://schemas.microsoft.com/office/drawing/2014/main" id="{7E8E5E43-BD26-4BD6-BB72-95A298D0D000}"/>
-              </a:ext>
-            </a:extLst>
-          </p:cNvPr>
+          <p:cNvPr id="4" name="TextBox 3"/>
           <p:cNvSpPr txBox="1"/>
           <p:nvPr/>
         </p:nvSpPr>
@@ -4303,20 +3824,15 @@
         </p:txBody>
       </p:sp>
     </p:spTree>
-    <p:extLst>
-      <p:ext uri="{BB962C8B-B14F-4D97-AF65-F5344CB8AC3E}">
-        <p14:creationId xmlns:p14="http://schemas.microsoft.com/office/powerpoint/2010/main" val="600882921"/>
-      </p:ext>
-    </p:extLst>
   </p:cSld>
   <p:clrMapOvr>
     <a:masterClrMapping/>
   </p:clrMapOvr>
-  <mc:AlternateContent xmlns:mc="http://schemas.openxmlformats.org/markup-compatibility/2006" xmlns:p14="http://schemas.microsoft.com/office/powerpoint/2010/main">
-    <mc:Choice Requires="p14">
+  <mc:AlternateContent xmlns:mc="http://schemas.openxmlformats.org/markup-compatibility/2006">
+    <mc:Choice xmlns:p14="http://schemas.microsoft.com/office/powerpoint/2010/main" Requires="p14">
       <p:transition spd="slow" p14:dur="2000" advTm="3118"/>
     </mc:Choice>
-    <mc:Fallback xmlns="">
+    <mc:Fallback>
       <p:transition spd="slow" advTm="3118"/>
     </mc:Fallback>
   </mc:AlternateContent>
@@ -4361,7 +3877,7 @@
           </a:bodyPr>
           <a:lstStyle/>
           <a:p>
-            <a:pPr algn="ctr" defTabSz="859536">
+            <a:pPr algn="ctr" defTabSz="859790">
               <a:spcAft>
                 <a:spcPts val="600"/>
               </a:spcAft>
@@ -4381,6 +3897,18 @@
               </a:rPr>
               <a:t>LEAD AND LAG</a:t>
             </a:r>
+            <a:endParaRPr lang="en-US" sz="3600" b="1" dirty="0">
+              <a:solidFill>
+                <a:srgbClr val="C00000"/>
+              </a:solidFill>
+              <a:effectLst>
+                <a:outerShdw blurRad="38100" dist="38100" dir="2700000" algn="tl">
+                  <a:srgbClr val="000000">
+                    <a:alpha val="43137"/>
+                  </a:srgbClr>
+                </a:outerShdw>
+              </a:effectLst>
+            </a:endParaRPr>
           </a:p>
         </p:txBody>
       </p:sp>
@@ -4405,7 +3933,7 @@
           </a:bodyPr>
           <a:lstStyle/>
           <a:p>
-            <a:pPr algn="ctr" defTabSz="859536">
+            <a:pPr algn="ctr" defTabSz="859790">
               <a:spcAft>
                 <a:spcPts val="600"/>
               </a:spcAft>
@@ -4440,9 +3968,21 @@
               </a:rPr>
               <a:t> is the acceleration of the successor activity.    </a:t>
             </a:r>
-          </a:p>
-          <a:p>
-            <a:pPr algn="ctr" defTabSz="859536">
+            <a:endParaRPr lang="en-US" dirty="0">
+              <a:solidFill>
+                <a:schemeClr val="dk1"/>
+              </a:solidFill>
+              <a:effectLst>
+                <a:outerShdw blurRad="38100" dist="38100" dir="2700000" algn="tl">
+                  <a:srgbClr val="000000">
+                    <a:alpha val="43137"/>
+                  </a:srgbClr>
+                </a:outerShdw>
+              </a:effectLst>
+            </a:endParaRPr>
+          </a:p>
+          <a:p>
+            <a:pPr algn="ctr" defTabSz="859790">
               <a:spcAft>
                 <a:spcPts val="600"/>
               </a:spcAft>
@@ -4498,7 +4038,7 @@
           </a:bodyPr>
           <a:lstStyle/>
           <a:p>
-            <a:pPr algn="ctr" defTabSz="859536">
+            <a:pPr algn="ctr" defTabSz="859790">
               <a:spcAft>
                 <a:spcPts val="600"/>
               </a:spcAft>
@@ -4533,9 +4073,21 @@
               </a:rPr>
               <a:t> indicate a delay in the predecessor activity. </a:t>
             </a:r>
-          </a:p>
-          <a:p>
-            <a:pPr algn="ctr" defTabSz="859536">
+            <a:endParaRPr lang="en-US" dirty="0">
+              <a:solidFill>
+                <a:schemeClr val="dk1"/>
+              </a:solidFill>
+              <a:effectLst>
+                <a:outerShdw blurRad="38100" dist="38100" dir="2700000" algn="tl">
+                  <a:srgbClr val="000000">
+                    <a:alpha val="43137"/>
+                  </a:srgbClr>
+                </a:outerShdw>
+              </a:effectLst>
+            </a:endParaRPr>
+          </a:p>
+          <a:p>
+            <a:pPr algn="ctr" defTabSz="859790">
               <a:spcAft>
                 <a:spcPts val="600"/>
               </a:spcAft>
@@ -4572,18 +4124,12 @@
       </p:sp>
       <p:pic>
         <p:nvPicPr>
-          <p:cNvPr id="12" name="Picture 11">
-            <a:extLst>
-              <a:ext uri="{FF2B5EF4-FFF2-40B4-BE49-F238E27FC236}">
-                <a16:creationId xmlns:a16="http://schemas.microsoft.com/office/drawing/2014/main" id="{389A39A5-2306-4E7B-8652-F5713E387BE9}"/>
-              </a:ext>
-            </a:extLst>
-          </p:cNvPr>
+          <p:cNvPr id="12" name="Picture 11"/>
           <p:cNvPicPr/>
           <p:nvPr/>
         </p:nvPicPr>
         <p:blipFill>
-          <a:blip r:embed="rId2"/>
+          <a:blip r:embed="rId1"/>
           <a:stretch>
             <a:fillRect/>
           </a:stretch>
@@ -4600,18 +4146,12 @@
       </p:pic>
       <p:pic>
         <p:nvPicPr>
-          <p:cNvPr id="13" name="Picture 12">
-            <a:extLst>
-              <a:ext uri="{FF2B5EF4-FFF2-40B4-BE49-F238E27FC236}">
-                <a16:creationId xmlns:a16="http://schemas.microsoft.com/office/drawing/2014/main" id="{8A7B1EC2-42B5-4013-BDD9-D5FC92E18C02}"/>
-              </a:ext>
-            </a:extLst>
-          </p:cNvPr>
+          <p:cNvPr id="13" name="Picture 12"/>
           <p:cNvPicPr/>
           <p:nvPr/>
         </p:nvPicPr>
         <p:blipFill>
-          <a:blip r:embed="rId3"/>
+          <a:blip r:embed="rId2"/>
           <a:stretch>
             <a:fillRect/>
           </a:stretch>
@@ -4627,11 +4167,6 @@
         </p:spPr>
       </p:pic>
     </p:spTree>
-    <p:extLst>
-      <p:ext uri="{BB962C8B-B14F-4D97-AF65-F5344CB8AC3E}">
-        <p14:creationId xmlns:p14="http://schemas.microsoft.com/office/powerpoint/2010/main" val="4114787762"/>
-      </p:ext>
-    </p:extLst>
   </p:cSld>
   <p:clrMapOvr>
     <a:masterClrMapping/>
@@ -4787,6 +4322,12 @@
               </a:rPr>
               <a:t>DEPENDENCY DETERMINATION</a:t>
             </a:r>
+            <a:endParaRPr lang="en-US" altLang="en-US" sz="3200" b="1" dirty="0">
+              <a:solidFill>
+                <a:schemeClr val="tx1"/>
+              </a:solidFill>
+              <a:latin typeface="Calibri" panose="020F0502020204030204" pitchFamily="34" charset="0"/>
+            </a:endParaRPr>
           </a:p>
           <a:p>
             <a:pPr marL="0" indent="0" eaLnBrk="1" hangingPunct="1">
@@ -4967,6 +4508,12 @@
               </a:rPr>
               <a:t>Example is adoption of new approach due to expertise.</a:t>
             </a:r>
+            <a:endParaRPr lang="en-US" altLang="en-US" sz="2800" i="1" dirty="0">
+              <a:solidFill>
+                <a:schemeClr val="tx1"/>
+              </a:solidFill>
+              <a:latin typeface="Gill Sans MT" pitchFamily="34" charset="0"/>
+            </a:endParaRPr>
           </a:p>
           <a:p>
             <a:pPr marL="0" algn="just" eaLnBrk="1" hangingPunct="1">
@@ -5037,6 +4584,12 @@
               </a:rPr>
               <a:t> </a:t>
             </a:r>
+            <a:endParaRPr lang="en-US" altLang="en-GB" sz="2800" dirty="0">
+              <a:solidFill>
+                <a:schemeClr val="tx1"/>
+              </a:solidFill>
+              <a:latin typeface="Gill Sans MT" pitchFamily="34" charset="0"/>
+            </a:endParaRPr>
           </a:p>
           <a:p>
             <a:pPr marL="0" algn="just" eaLnBrk="1" hangingPunct="1">
@@ -5100,11 +4653,6 @@
         </p:txBody>
       </p:sp>
     </p:spTree>
-    <p:extLst>
-      <p:ext uri="{BB962C8B-B14F-4D97-AF65-F5344CB8AC3E}">
-        <p14:creationId xmlns:p14="http://schemas.microsoft.com/office/powerpoint/2010/main" val="1400455867"/>
-      </p:ext>
-    </p:extLst>
   </p:cSld>
   <p:clrMapOvr>
     <a:masterClrMapping/>
@@ -5131,13 +4679,7 @@
       </p:grpSpPr>
       <p:sp>
         <p:nvSpPr>
-          <p:cNvPr id="2" name="TextBox 1">
-            <a:extLst>
-              <a:ext uri="{FF2B5EF4-FFF2-40B4-BE49-F238E27FC236}">
-                <a16:creationId xmlns:a16="http://schemas.microsoft.com/office/drawing/2014/main" id="{C2BF444A-B85F-4E6B-BB14-1E8C9ACA8EC2}"/>
-              </a:ext>
-            </a:extLst>
-          </p:cNvPr>
+          <p:cNvPr id="2" name="TextBox 1"/>
           <p:cNvSpPr txBox="1"/>
           <p:nvPr/>
         </p:nvSpPr>
@@ -5166,24 +4708,33 @@
               </a:rPr>
               <a:t>Resource availability </a:t>
             </a:r>
+            <a:endParaRPr lang="en-US" b="1" u="sng" dirty="0">
+              <a:solidFill>
+                <a:srgbClr val="FF0000"/>
+              </a:solidFill>
+              <a:effectLst/>
+            </a:endParaRPr>
           </a:p>
           <a:p>
             <a:r>
               <a:rPr lang="en-US" dirty="0"/>
               <a:t>fundamentally shapes project schedules by dictating what's possible, directly causing delays, extending project duration, altering critical paths, and impacting costs and quality when resources (people, equipment, funds) are scarce or misaligned with task demands, leading to bottlenecks, idle time, or rushed work, necessitating realistic resource-constrained scheduling to balance capacity and needs.</a:t>
             </a:r>
+            <a:endParaRPr lang="en-US" dirty="0"/>
           </a:p>
           <a:p>
             <a:r>
               <a:rPr lang="en-US" b="1" dirty="0"/>
               <a:t>Good resource management ensures the right resources are available at the right time, maximizing productivity and outcomes; poor management creates delays, budget overruns, and dissatisfaction, highlighting the need for realistic scheduling that accounts for resource limits</a:t>
             </a:r>
+            <a:endParaRPr lang="en-US" b="1" dirty="0"/>
           </a:p>
           <a:p>
             <a:r>
               <a:rPr lang="en-US" dirty="0"/>
               <a:t> </a:t>
             </a:r>
+            <a:endParaRPr lang="en-US" dirty="0"/>
           </a:p>
           <a:p>
             <a:r>
@@ -5194,6 +4745,11 @@
               </a:rPr>
               <a:t>Key Impacts on Schedules</a:t>
             </a:r>
+            <a:endParaRPr lang="en-US" b="1" u="sng" dirty="0">
+              <a:solidFill>
+                <a:srgbClr val="FF0000"/>
+              </a:solidFill>
+            </a:endParaRPr>
           </a:p>
           <a:p>
             <a:pPr>
@@ -5208,6 +4764,7 @@
               <a:rPr lang="en-US" dirty="0"/>
               <a:t> Insufficient resources at the right time force tasks to start late, extending the entire project timeline.</a:t>
             </a:r>
+            <a:endParaRPr lang="en-US" dirty="0"/>
           </a:p>
           <a:p>
             <a:pPr>
@@ -5216,7 +4773,7 @@
             </a:pPr>
             <a:r>
               <a:rPr lang="en-US" b="1" dirty="0">
-                <a:hlinkClick r:id="rId2"/>
+                <a:hlinkClick r:id="rId1"/>
               </a:rPr>
               <a:t>Critical Path</a:t>
             </a:r>
@@ -5228,6 +4785,7 @@
               <a:rPr lang="en-US" dirty="0"/>
               <a:t> Limited resources can make previously non-critical tasks critical, creating new dependencies and increasing schedule sensitivity, as shown in this YouTube video.</a:t>
             </a:r>
+            <a:endParaRPr lang="en-US" dirty="0"/>
           </a:p>
           <a:p>
             <a:pPr>
@@ -5242,6 +4800,7 @@
               <a:rPr lang="en-US" dirty="0"/>
               <a:t> Delays often lead to higher costs; to compensate, scope might be cut or quality compromised, affecting deliverables.</a:t>
             </a:r>
+            <a:endParaRPr lang="en-US" dirty="0"/>
           </a:p>
           <a:p>
             <a:pPr>
@@ -5256,6 +4815,7 @@
               <a:rPr lang="en-US" dirty="0"/>
               <a:t> Over-allocation of a resource creates bottlenecks, while under-utilization leads to wasted time and money.</a:t>
             </a:r>
+            <a:endParaRPr lang="en-US" dirty="0"/>
           </a:p>
           <a:p>
             <a:pPr>
@@ -5270,12 +4830,14 @@
               <a:rPr lang="en-US" dirty="0"/>
               <a:t> Resource constraints make schedules less flexible, requiring tighter sequencing and making changes harder to absorb. </a:t>
             </a:r>
+            <a:endParaRPr lang="en-US" dirty="0"/>
           </a:p>
           <a:p>
             <a:r>
               <a:rPr lang="en-US" dirty="0"/>
               <a:t>How Resource Availability Changes Planning</a:t>
             </a:r>
+            <a:endParaRPr lang="en-US" dirty="0"/>
           </a:p>
           <a:p>
             <a:pPr>
@@ -5290,6 +4852,7 @@
               <a:rPr lang="en-US" dirty="0"/>
               <a:t> Instead of fixing time and adjusting resources, this approach fixes resources (within capacity) and adjusts time, creating more realistic plans.</a:t>
             </a:r>
+            <a:endParaRPr lang="en-US" dirty="0"/>
           </a:p>
           <a:p>
             <a:pPr>
@@ -5304,6 +4867,7 @@
               <a:rPr lang="en-US" dirty="0"/>
               <a:t> When resources are scarce, some tasks must be delayed to prioritize others, often based on strategic importance.</a:t>
             </a:r>
+            <a:endParaRPr lang="en-US" dirty="0"/>
           </a:p>
           <a:p>
             <a:pPr>
@@ -5318,15 +4882,11 @@
               <a:rPr lang="en-US" dirty="0"/>
               <a:t> Effective tracking balances work across team members, preventing burnout and maximizing overall output. </a:t>
             </a:r>
+            <a:endParaRPr lang="en-US" dirty="0"/>
           </a:p>
         </p:txBody>
       </p:sp>
     </p:spTree>
-    <p:extLst>
-      <p:ext uri="{BB962C8B-B14F-4D97-AF65-F5344CB8AC3E}">
-        <p14:creationId xmlns:p14="http://schemas.microsoft.com/office/powerpoint/2010/main" val="1476800829"/>
-      </p:ext>
-    </p:extLst>
   </p:cSld>
   <p:clrMapOvr>
     <a:masterClrMapping/>
@@ -5353,13 +4913,7 @@
       </p:grpSpPr>
       <p:sp>
         <p:nvSpPr>
-          <p:cNvPr id="2" name="TextBox 1">
-            <a:extLst>
-              <a:ext uri="{FF2B5EF4-FFF2-40B4-BE49-F238E27FC236}">
-                <a16:creationId xmlns:a16="http://schemas.microsoft.com/office/drawing/2014/main" id="{F12BCFCF-7BFA-475A-9588-0CBEE7EEF747}"/>
-              </a:ext>
-            </a:extLst>
-          </p:cNvPr>
+          <p:cNvPr id="2" name="TextBox 1"/>
           <p:cNvSpPr txBox="1"/>
           <p:nvPr/>
         </p:nvSpPr>
@@ -5499,6 +5053,12 @@
               </a:rPr>
               <a:t>.</a:t>
             </a:r>
+            <a:endParaRPr lang="en-US" sz="1800" kern="0" dirty="0">
+              <a:effectLst/>
+              <a:latin typeface="Times New Roman" panose="02020603050405020304" pitchFamily="18" charset="0"/>
+              <a:ea typeface="Times New Roman" panose="02020603050405020304" pitchFamily="18" charset="0"/>
+              <a:cs typeface="Times New Roman" panose="02020603050405020304" pitchFamily="18" charset="0"/>
+            </a:endParaRPr>
           </a:p>
           <a:p>
             <a:pPr marL="0" marR="0">
@@ -5582,20 +5142,14 @@
       </p:sp>
       <p:pic>
         <p:nvPicPr>
-          <p:cNvPr id="4" name="Picture 3">
-            <a:extLst>
-              <a:ext uri="{FF2B5EF4-FFF2-40B4-BE49-F238E27FC236}">
-                <a16:creationId xmlns:a16="http://schemas.microsoft.com/office/drawing/2014/main" id="{DAB1FDB7-743A-4232-AF1E-B1184856AFAA}"/>
-              </a:ext>
-            </a:extLst>
-          </p:cNvPr>
+          <p:cNvPr id="4" name="Picture 3"/>
           <p:cNvPicPr>
             <a:picLocks noChangeAspect="1"/>
           </p:cNvPicPr>
           <p:nvPr/>
         </p:nvPicPr>
         <p:blipFill>
-          <a:blip r:embed="rId2">
+          <a:blip r:embed="rId1">
             <a:extLst>
               <a:ext uri="{28A0092B-C50C-407E-A947-70E740481C1C}">
                 <a14:useLocalDpi xmlns:a14="http://schemas.microsoft.com/office/drawing/2010/main" val="0"/>
@@ -5617,11 +5171,6 @@
         </p:spPr>
       </p:pic>
     </p:spTree>
-    <p:extLst>
-      <p:ext uri="{BB962C8B-B14F-4D97-AF65-F5344CB8AC3E}">
-        <p14:creationId xmlns:p14="http://schemas.microsoft.com/office/powerpoint/2010/main" val="2420508203"/>
-      </p:ext>
-    </p:extLst>
   </p:cSld>
   <p:clrMapOvr>
     <a:masterClrMapping/>
@@ -5648,23 +5197,11 @@
       </p:grpSpPr>
       <p:graphicFrame>
         <p:nvGraphicFramePr>
-          <p:cNvPr id="2" name="Table 1">
-            <a:extLst>
-              <a:ext uri="{FF2B5EF4-FFF2-40B4-BE49-F238E27FC236}">
-                <a16:creationId xmlns:a16="http://schemas.microsoft.com/office/drawing/2014/main" id="{84D9B9C9-4769-46F0-BBF9-307BAC633C1E}"/>
-              </a:ext>
-            </a:extLst>
-          </p:cNvPr>
+          <p:cNvPr id="2" name="Table 1"/>
           <p:cNvGraphicFramePr>
             <a:graphicFrameLocks noGrp="1"/>
           </p:cNvGraphicFramePr>
-          <p:nvPr>
-            <p:extLst>
-              <p:ext uri="{D42A27DB-BD31-4B8C-83A1-F6EECF244321}">
-                <p14:modId xmlns:p14="http://schemas.microsoft.com/office/powerpoint/2010/main" val="637851915"/>
-              </p:ext>
-            </p:extLst>
-          </p:nvPr>
+          <p:nvPr/>
         </p:nvGraphicFramePr>
         <p:xfrm>
           <a:off x="259645" y="711200"/>
@@ -5677,20 +5214,8 @@
                 <a:tableStyleId>{5C22544A-7EE6-4342-B048-85BDC9FD1C3A}</a:tableStyleId>
               </a:tblPr>
               <a:tblGrid>
-                <a:gridCol w="3581791">
-                  <a:extLst>
-                    <a:ext uri="{9D8B030D-6E8A-4147-A177-3AD203B41FA5}">
-                      <a16:colId xmlns:a16="http://schemas.microsoft.com/office/drawing/2014/main" val="3003088466"/>
-                    </a:ext>
-                  </a:extLst>
-                </a:gridCol>
-                <a:gridCol w="8090919">
-                  <a:extLst>
-                    <a:ext uri="{9D8B030D-6E8A-4147-A177-3AD203B41FA5}">
-                      <a16:colId xmlns:a16="http://schemas.microsoft.com/office/drawing/2014/main" val="2173268587"/>
-                    </a:ext>
-                  </a:extLst>
-                </a:gridCol>
+                <a:gridCol w="3581791"/>
+                <a:gridCol w="8090919"/>
               </a:tblGrid>
               <a:tr h="173148">
                 <a:tc>
@@ -5757,11 +5282,6 @@
                   </a:txBody>
                   <a:tcPr marL="8761" marR="8761" marT="8761" marB="8761" anchor="ctr"/>
                 </a:tc>
-                <a:extLst>
-                  <a:ext uri="{0D108BD9-81ED-4DB2-BD59-A6C34878D82A}">
-                    <a16:rowId xmlns:a16="http://schemas.microsoft.com/office/drawing/2014/main" val="3893472297"/>
-                  </a:ext>
-                </a:extLst>
               </a:tr>
               <a:tr h="286052">
                 <a:tc>
@@ -5818,15 +5338,13 @@
                         </a:rPr>
                         <a:t>The total approved cost estimate for the project, including all planned expenses.</a:t>
                       </a:r>
+                      <a:endParaRPr lang="en-US" sz="1600" kern="0" dirty="0">
+                        <a:effectLst/>
+                      </a:endParaRPr>
                     </a:p>
                   </a:txBody>
                   <a:tcPr marL="8761" marR="8761" marT="8761" marB="8761" anchor="ctr"/>
                 </a:tc>
-                <a:extLst>
-                  <a:ext uri="{0D108BD9-81ED-4DB2-BD59-A6C34878D82A}">
-                    <a16:rowId xmlns:a16="http://schemas.microsoft.com/office/drawing/2014/main" val="155133489"/>
-                  </a:ext>
-                </a:extLst>
               </a:tr>
               <a:tr h="286052">
                 <a:tc>
@@ -5893,11 +5411,6 @@
                   </a:txBody>
                   <a:tcPr marL="8761" marR="8761" marT="8761" marB="8761" anchor="ctr"/>
                 </a:tc>
-                <a:extLst>
-                  <a:ext uri="{0D108BD9-81ED-4DB2-BD59-A6C34878D82A}">
-                    <a16:rowId xmlns:a16="http://schemas.microsoft.com/office/drawing/2014/main" val="1991467594"/>
-                  </a:ext>
-                </a:extLst>
               </a:tr>
               <a:tr h="286052">
                 <a:tc>
@@ -5964,11 +5477,6 @@
                   </a:txBody>
                   <a:tcPr marL="8761" marR="8761" marT="8761" marB="8761" anchor="ctr"/>
                 </a:tc>
-                <a:extLst>
-                  <a:ext uri="{0D108BD9-81ED-4DB2-BD59-A6C34878D82A}">
-                    <a16:rowId xmlns:a16="http://schemas.microsoft.com/office/drawing/2014/main" val="4158128282"/>
-                  </a:ext>
-                </a:extLst>
               </a:tr>
               <a:tr h="286052">
                 <a:tc>
@@ -6035,11 +5543,6 @@
                   </a:txBody>
                   <a:tcPr marL="8761" marR="8761" marT="8761" marB="8761" anchor="ctr"/>
                 </a:tc>
-                <a:extLst>
-                  <a:ext uri="{0D108BD9-81ED-4DB2-BD59-A6C34878D82A}">
-                    <a16:rowId xmlns:a16="http://schemas.microsoft.com/office/drawing/2014/main" val="316735517"/>
-                  </a:ext>
-                </a:extLst>
               </a:tr>
               <a:tr h="563744">
                 <a:tc>
@@ -6106,11 +5609,6 @@
                   </a:txBody>
                   <a:tcPr marL="8761" marR="8761" marT="8761" marB="8761" anchor="ctr"/>
                 </a:tc>
-                <a:extLst>
-                  <a:ext uri="{0D108BD9-81ED-4DB2-BD59-A6C34878D82A}">
-                    <a16:rowId xmlns:a16="http://schemas.microsoft.com/office/drawing/2014/main" val="2850290782"/>
-                  </a:ext>
-                </a:extLst>
               </a:tr>
               <a:tr h="286052">
                 <a:tc>
@@ -6177,11 +5675,6 @@
                   </a:txBody>
                   <a:tcPr marL="8761" marR="8761" marT="8761" marB="8761" anchor="ctr"/>
                 </a:tc>
-                <a:extLst>
-                  <a:ext uri="{0D108BD9-81ED-4DB2-BD59-A6C34878D82A}">
-                    <a16:rowId xmlns:a16="http://schemas.microsoft.com/office/drawing/2014/main" val="2007286843"/>
-                  </a:ext>
-                </a:extLst>
               </a:tr>
               <a:tr h="286052">
                 <a:tc>
@@ -6248,11 +5741,6 @@
                   </a:txBody>
                   <a:tcPr marL="8761" marR="8761" marT="8761" marB="8761" anchor="ctr"/>
                 </a:tc>
-                <a:extLst>
-                  <a:ext uri="{0D108BD9-81ED-4DB2-BD59-A6C34878D82A}">
-                    <a16:rowId xmlns:a16="http://schemas.microsoft.com/office/drawing/2014/main" val="3978252533"/>
-                  </a:ext>
-                </a:extLst>
               </a:tr>
               <a:tr h="286052">
                 <a:tc>
@@ -6319,11 +5807,6 @@
                   </a:txBody>
                   <a:tcPr marL="8761" marR="8761" marT="8761" marB="8761" anchor="ctr"/>
                 </a:tc>
-                <a:extLst>
-                  <a:ext uri="{0D108BD9-81ED-4DB2-BD59-A6C34878D82A}">
-                    <a16:rowId xmlns:a16="http://schemas.microsoft.com/office/drawing/2014/main" val="3488252361"/>
-                  </a:ext>
-                </a:extLst>
               </a:tr>
               <a:tr h="286052">
                 <a:tc>
@@ -6390,11 +5873,6 @@
                   </a:txBody>
                   <a:tcPr marL="8761" marR="8761" marT="8761" marB="8761" anchor="ctr"/>
                 </a:tc>
-                <a:extLst>
-                  <a:ext uri="{0D108BD9-81ED-4DB2-BD59-A6C34878D82A}">
-                    <a16:rowId xmlns:a16="http://schemas.microsoft.com/office/drawing/2014/main" val="2324319991"/>
-                  </a:ext>
-                </a:extLst>
               </a:tr>
               <a:tr h="286052">
                 <a:tc>
@@ -6461,11 +5939,6 @@
                   </a:txBody>
                   <a:tcPr marL="8761" marR="8761" marT="8761" marB="8761" anchor="ctr"/>
                 </a:tc>
-                <a:extLst>
-                  <a:ext uri="{0D108BD9-81ED-4DB2-BD59-A6C34878D82A}">
-                    <a16:rowId xmlns:a16="http://schemas.microsoft.com/office/drawing/2014/main" val="2041775900"/>
-                  </a:ext>
-                </a:extLst>
               </a:tr>
               <a:tr h="286052">
                 <a:tc>
@@ -6532,11 +6005,6 @@
                   </a:txBody>
                   <a:tcPr marL="8761" marR="8761" marT="8761" marB="8761" anchor="ctr"/>
                 </a:tc>
-                <a:extLst>
-                  <a:ext uri="{0D108BD9-81ED-4DB2-BD59-A6C34878D82A}">
-                    <a16:rowId xmlns:a16="http://schemas.microsoft.com/office/drawing/2014/main" val="3539699052"/>
-                  </a:ext>
-                </a:extLst>
               </a:tr>
               <a:tr h="563744">
                 <a:tc>
@@ -6603,11 +6071,6 @@
                   </a:txBody>
                   <a:tcPr marL="8761" marR="8761" marT="8761" marB="8761" anchor="ctr"/>
                 </a:tc>
-                <a:extLst>
-                  <a:ext uri="{0D108BD9-81ED-4DB2-BD59-A6C34878D82A}">
-                    <a16:rowId xmlns:a16="http://schemas.microsoft.com/office/drawing/2014/main" val="4173563297"/>
-                  </a:ext>
-                </a:extLst>
               </a:tr>
               <a:tr h="286052">
                 <a:tc>
@@ -6674,11 +6137,6 @@
                   </a:txBody>
                   <a:tcPr marL="8761" marR="8761" marT="8761" marB="8761" anchor="ctr"/>
                 </a:tc>
-                <a:extLst>
-                  <a:ext uri="{0D108BD9-81ED-4DB2-BD59-A6C34878D82A}">
-                    <a16:rowId xmlns:a16="http://schemas.microsoft.com/office/drawing/2014/main" val="57628773"/>
-                  </a:ext>
-                </a:extLst>
               </a:tr>
               <a:tr h="563744">
                 <a:tc>
@@ -6757,11 +6215,6 @@
                   </a:txBody>
                   <a:tcPr marL="8761" marR="8761" marT="8761" marB="8761" anchor="ctr"/>
                 </a:tc>
-                <a:extLst>
-                  <a:ext uri="{0D108BD9-81ED-4DB2-BD59-A6C34878D82A}">
-                    <a16:rowId xmlns:a16="http://schemas.microsoft.com/office/drawing/2014/main" val="3573622504"/>
-                  </a:ext>
-                </a:extLst>
               </a:tr>
               <a:tr h="286052">
                 <a:tc>
@@ -6840,11 +6293,6 @@
                   </a:txBody>
                   <a:tcPr marL="8761" marR="8761" marT="8761" marB="8761" anchor="ctr"/>
                 </a:tc>
-                <a:extLst>
-                  <a:ext uri="{0D108BD9-81ED-4DB2-BD59-A6C34878D82A}">
-                    <a16:rowId xmlns:a16="http://schemas.microsoft.com/office/drawing/2014/main" val="2749463791"/>
-                  </a:ext>
-                </a:extLst>
               </a:tr>
               <a:tr h="286052">
                 <a:tc>
@@ -6911,11 +6359,6 @@
                   </a:txBody>
                   <a:tcPr marL="8761" marR="8761" marT="8761" marB="8761" anchor="ctr"/>
                 </a:tc>
-                <a:extLst>
-                  <a:ext uri="{0D108BD9-81ED-4DB2-BD59-A6C34878D82A}">
-                    <a16:rowId xmlns:a16="http://schemas.microsoft.com/office/drawing/2014/main" val="1430120804"/>
-                  </a:ext>
-                </a:extLst>
               </a:tr>
               <a:tr h="563744">
                 <a:tc>
@@ -6982,11 +6425,6 @@
                   </a:txBody>
                   <a:tcPr marL="8761" marR="8761" marT="8761" marB="8761" anchor="ctr"/>
                 </a:tc>
-                <a:extLst>
-                  <a:ext uri="{0D108BD9-81ED-4DB2-BD59-A6C34878D82A}">
-                    <a16:rowId xmlns:a16="http://schemas.microsoft.com/office/drawing/2014/main" val="1755267479"/>
-                  </a:ext>
-                </a:extLst>
               </a:tr>
             </a:tbl>
           </a:graphicData>
@@ -6994,13 +6432,7 @@
       </p:graphicFrame>
       <p:sp>
         <p:nvSpPr>
-          <p:cNvPr id="4" name="TextBox 3">
-            <a:extLst>
-              <a:ext uri="{FF2B5EF4-FFF2-40B4-BE49-F238E27FC236}">
-                <a16:creationId xmlns:a16="http://schemas.microsoft.com/office/drawing/2014/main" id="{3E448282-A609-4C8E-BE99-A152B06CAFE6}"/>
-              </a:ext>
-            </a:extLst>
-          </p:cNvPr>
+          <p:cNvPr id="4" name="TextBox 3"/>
           <p:cNvSpPr txBox="1"/>
           <p:nvPr/>
         </p:nvSpPr>
@@ -7033,11 +6465,6 @@
         </p:txBody>
       </p:sp>
     </p:spTree>
-    <p:extLst>
-      <p:ext uri="{BB962C8B-B14F-4D97-AF65-F5344CB8AC3E}">
-        <p14:creationId xmlns:p14="http://schemas.microsoft.com/office/powerpoint/2010/main" val="1482879744"/>
-      </p:ext>
-    </p:extLst>
   </p:cSld>
   <p:clrMapOvr>
     <a:masterClrMapping/>
@@ -7064,13 +6491,7 @@
       </p:grpSpPr>
       <p:sp>
         <p:nvSpPr>
-          <p:cNvPr id="2" name="TextBox 1">
-            <a:extLst>
-              <a:ext uri="{FF2B5EF4-FFF2-40B4-BE49-F238E27FC236}">
-                <a16:creationId xmlns:a16="http://schemas.microsoft.com/office/drawing/2014/main" id="{F12BCFCF-7BFA-475A-9588-0CBEE7EEF747}"/>
-              </a:ext>
-            </a:extLst>
-          </p:cNvPr>
+          <p:cNvPr id="2" name="TextBox 1"/>
           <p:cNvSpPr txBox="1"/>
           <p:nvPr/>
         </p:nvSpPr>
@@ -7102,6 +6523,7 @@
               <a:rPr lang="en-US" sz="2400" dirty="0"/>
               <a:t> The overarching process of sourcing, negotiating, and strategically acquiring goods, services, or works from an external source, often involving a competitive bidding process.</a:t>
             </a:r>
+            <a:endParaRPr lang="en-US" sz="2400" dirty="0"/>
           </a:p>
           <a:p>
             <a:r>
@@ -7112,6 +6534,7 @@
               <a:rPr lang="en-US" sz="2400" dirty="0"/>
               <a:t> A company or individual that provides goods or services to another entity.</a:t>
             </a:r>
+            <a:endParaRPr lang="en-US" sz="2400" dirty="0"/>
           </a:p>
           <a:p>
             <a:pPr>
@@ -7126,6 +6549,7 @@
               <a:rPr lang="en-US" sz="2400" dirty="0"/>
               <a:t> A legally binding agreement between a buyer and a supplier that defines the terms, conditions, rights, and obligations regarding the purchase of goods or services.</a:t>
             </a:r>
+            <a:endParaRPr lang="en-US" sz="2400" dirty="0"/>
           </a:p>
           <a:p>
             <a:pPr>
@@ -7165,6 +6589,7 @@
               <a:rPr lang="en-US" altLang="en-GB" sz="2400" dirty="0"/>
               <a:t>is a top-bottom estimating technique used for estimating the project duration or cost of an activity using historical data from a similar activity or project. It is generally less costly, less accurate and less time-consuming but most reliable. It is ideal for management use.</a:t>
             </a:r>
+            <a:endParaRPr lang="en-US" altLang="en-GB" sz="2400" dirty="0"/>
           </a:p>
           <a:p>
             <a:pPr marL="342900" indent="-228600" algn="just">
@@ -7197,6 +6622,7 @@
               <a:rPr lang="en-US" altLang="en-GB" sz="2400" dirty="0"/>
               <a:t>Bottom-up estimating is a method of estimating project duration or cost by aggregating the estimates of the work packages. It is time consuming, but most accurate of all the estimating techniques</a:t>
             </a:r>
+            <a:endParaRPr lang="en-US" altLang="en-GB" sz="2400" dirty="0"/>
           </a:p>
           <a:p>
             <a:endParaRPr lang="en-US" dirty="0"/>
@@ -7204,11 +6630,6 @@
         </p:txBody>
       </p:sp>
     </p:spTree>
-    <p:extLst>
-      <p:ext uri="{BB962C8B-B14F-4D97-AF65-F5344CB8AC3E}">
-        <p14:creationId xmlns:p14="http://schemas.microsoft.com/office/powerpoint/2010/main" val="2484616892"/>
-      </p:ext>
-    </p:extLst>
   </p:cSld>
   <p:clrMapOvr>
     <a:masterClrMapping/>
@@ -7266,6 +6687,9 @@
               </a:rPr>
               <a:t>:</a:t>
             </a:r>
+            <a:endParaRPr lang="en-US" sz="2400" dirty="0">
+              <a:latin typeface="Gill Sans MT" pitchFamily="34" charset="0"/>
+            </a:endParaRPr>
           </a:p>
           <a:p>
             <a:pPr marL="342900" indent="-342900" algn="just">
@@ -7291,6 +6715,9 @@
               </a:rPr>
               <a:t>Estimates are better done in range.  For example, range of -25 to +75% is at the start of exploring a project opportunity, while projects that are well along in their life cycle may have an estimating range of -5 to +10%.</a:t>
             </a:r>
+            <a:endParaRPr lang="en-US" sz="2400" dirty="0">
+              <a:latin typeface="Gill Sans MT" pitchFamily="34" charset="0"/>
+            </a:endParaRPr>
           </a:p>
           <a:p>
             <a:pPr marL="342900" indent="-228600" algn="just">
@@ -7328,6 +6755,9 @@
               </a:rPr>
               <a:t>is a top-bottom estimating technique used for estimating the project duration or cost of an activity using historical data from a similar activity or project. It is generally less costly, less accurate and less time-consuming but most reliable. It is ideal for management use.</a:t>
             </a:r>
+            <a:endParaRPr lang="en-US" altLang="en-GB" sz="2400" dirty="0">
+              <a:latin typeface="Gill Sans MT" pitchFamily="34" charset="0"/>
+            </a:endParaRPr>
           </a:p>
           <a:p>
             <a:pPr marL="342900" indent="-228600" algn="just">
@@ -7365,6 +6795,9 @@
               </a:rPr>
               <a:t>Bottom-up estimating is a method of estimating project duration or cost by aggregating the estimates of the work packages. It is time consuming, but most accurate of all the estimating techniques</a:t>
             </a:r>
+            <a:endParaRPr lang="en-US" altLang="en-GB" sz="2400" dirty="0">
+              <a:latin typeface="Gill Sans MT" pitchFamily="34" charset="0"/>
+            </a:endParaRPr>
           </a:p>
           <a:p>
             <a:pPr marL="342900" indent="-228600" algn="just">
@@ -7421,11 +6854,6 @@
         </p:txBody>
       </p:sp>
     </p:spTree>
-    <p:extLst>
-      <p:ext uri="{BB962C8B-B14F-4D97-AF65-F5344CB8AC3E}">
-        <p14:creationId xmlns:p14="http://schemas.microsoft.com/office/powerpoint/2010/main" val="2734029551"/>
-      </p:ext>
-    </p:extLst>
   </p:cSld>
   <p:clrMapOvr>
     <a:masterClrMapping/>
@@ -7452,13 +6880,7 @@
       </p:grpSpPr>
       <p:sp>
         <p:nvSpPr>
-          <p:cNvPr id="2" name="TextBox 1">
-            <a:extLst>
-              <a:ext uri="{FF2B5EF4-FFF2-40B4-BE49-F238E27FC236}">
-                <a16:creationId xmlns:a16="http://schemas.microsoft.com/office/drawing/2014/main" id="{1DF819B8-1614-4B4B-957E-1CF6579B3787}"/>
-              </a:ext>
-            </a:extLst>
-          </p:cNvPr>
+          <p:cNvPr id="2" name="TextBox 1"/>
           <p:cNvSpPr txBox="1"/>
           <p:nvPr/>
         </p:nvSpPr>
@@ -7482,15 +6904,11 @@
               <a:rPr lang="en-US" sz="3600" dirty="0"/>
               <a:t>QUIZ</a:t>
             </a:r>
+            <a:endParaRPr lang="en-US" sz="3600" dirty="0"/>
           </a:p>
         </p:txBody>
       </p:sp>
     </p:spTree>
-    <p:extLst>
-      <p:ext uri="{BB962C8B-B14F-4D97-AF65-F5344CB8AC3E}">
-        <p14:creationId xmlns:p14="http://schemas.microsoft.com/office/powerpoint/2010/main" val="1146667742"/>
-      </p:ext>
-    </p:extLst>
   </p:cSld>
   <p:clrMapOvr>
     <a:masterClrMapping/>
@@ -7543,25 +6961,22 @@
               </a:rPr>
               <a:t>PROJECT SCHEDULE MANAGEMENT </a:t>
             </a:r>
+            <a:endParaRPr lang="en-US" sz="2800" b="1" dirty="0">
+              <a:latin typeface="Gill Sans MT" pitchFamily="34" charset="0"/>
+            </a:endParaRPr>
           </a:p>
         </p:txBody>
       </p:sp>
       <p:pic>
         <p:nvPicPr>
-          <p:cNvPr id="5" name="Picture 4">
-            <a:extLst>
-              <a:ext uri="{FF2B5EF4-FFF2-40B4-BE49-F238E27FC236}">
-                <a16:creationId xmlns:a16="http://schemas.microsoft.com/office/drawing/2014/main" id="{F8EF3EEE-12F3-457F-95FA-B79B76404CC2}"/>
-              </a:ext>
-            </a:extLst>
-          </p:cNvPr>
+          <p:cNvPr id="5" name="Picture 4"/>
           <p:cNvPicPr>
             <a:picLocks noChangeAspect="1"/>
           </p:cNvPicPr>
           <p:nvPr/>
         </p:nvPicPr>
         <p:blipFill>
-          <a:blip r:embed="rId2"/>
+          <a:blip r:embed="rId1"/>
           <a:stretch>
             <a:fillRect/>
           </a:stretch>
@@ -7578,13 +6993,7 @@
       </p:pic>
       <p:sp>
         <p:nvSpPr>
-          <p:cNvPr id="2" name="TextBox 1">
-            <a:extLst>
-              <a:ext uri="{FF2B5EF4-FFF2-40B4-BE49-F238E27FC236}">
-                <a16:creationId xmlns:a16="http://schemas.microsoft.com/office/drawing/2014/main" id="{DAE110C8-797F-4CA0-9936-F1A160F88246}"/>
-              </a:ext>
-            </a:extLst>
-          </p:cNvPr>
+          <p:cNvPr id="2" name="TextBox 1"/>
           <p:cNvSpPr txBox="1"/>
           <p:nvPr/>
         </p:nvSpPr>
@@ -7633,6 +7042,12 @@
               </a:rPr>
               <a:t> is the process of defining project activities, estimating their duration, sequencing them logically, and assigning resources to ensure the project is completed within the planned time frame. </a:t>
             </a:r>
+            <a:endParaRPr lang="en-US" sz="1800" kern="0" dirty="0">
+              <a:effectLst/>
+              <a:latin typeface="Times New Roman" panose="02020603050405020304" pitchFamily="18" charset="0"/>
+              <a:ea typeface="Times New Roman" panose="02020603050405020304" pitchFamily="18" charset="0"/>
+              <a:cs typeface="Times New Roman" panose="02020603050405020304" pitchFamily="18" charset="0"/>
+            </a:endParaRPr>
           </a:p>
           <a:p>
             <a:pPr marL="0" marR="0">
@@ -7686,11 +7101,6 @@
         </p:txBody>
       </p:sp>
     </p:spTree>
-    <p:extLst>
-      <p:ext uri="{BB962C8B-B14F-4D97-AF65-F5344CB8AC3E}">
-        <p14:creationId xmlns:p14="http://schemas.microsoft.com/office/powerpoint/2010/main" val="281740372"/>
-      </p:ext>
-    </p:extLst>
   </p:cSld>
   <p:clrMapOvr>
     <a:masterClrMapping/>
@@ -7717,26 +7127,11 @@
       </p:grpSpPr>
       <p:sp useBgFill="1">
         <p:nvSpPr>
-          <p:cNvPr id="9" name="Rectangle 8">
-            <a:extLst>
-              <a:ext uri="{FF2B5EF4-FFF2-40B4-BE49-F238E27FC236}">
-                <a16:creationId xmlns:a16="http://schemas.microsoft.com/office/drawing/2014/main" id="{21A75659-5A6F-4F77-9679-678A00B9D8DC}"/>
-              </a:ext>
-              <a:ext uri="{C183D7F6-B498-43B3-948B-1728B52AA6E4}">
-                <adec:decorative xmlns:adec="http://schemas.microsoft.com/office/drawing/2017/decorative" val="1"/>
-              </a:ext>
-            </a:extLst>
-          </p:cNvPr>
+          <p:cNvPr id="9" name="Rectangle 8"/>
           <p:cNvSpPr>
             <a:spLocks noGrp="1" noRot="1" noChangeAspect="1" noMove="1" noResize="1" noEditPoints="1" noAdjustHandles="1" noChangeArrowheads="1" noChangeShapeType="1" noTextEdit="1"/>
           </p:cNvSpPr>
-          <p:nvPr>
-            <p:extLst>
-              <p:ext uri="{386F3935-93C4-4BCD-93E2-E3B085C9AB24}">
-                <p16:designElem xmlns:p16="http://schemas.microsoft.com/office/powerpoint/2015/main" val="1"/>
-              </p:ext>
-            </p:extLst>
-          </p:nvPr>
+          <p:nvPr/>
         </p:nvSpPr>
         <p:spPr>
           <a:xfrm>
@@ -7777,22 +7172,18 @@
       </p:sp>
       <p:pic>
         <p:nvPicPr>
-          <p:cNvPr id="5" name="Picture 4" descr="Graph on document with pen">
-            <a:extLst>
-              <a:ext uri="{FF2B5EF4-FFF2-40B4-BE49-F238E27FC236}">
-                <a16:creationId xmlns:a16="http://schemas.microsoft.com/office/drawing/2014/main" id="{BFAF30B6-0B71-7927-E000-DFBD62D1585D}"/>
-              </a:ext>
-            </a:extLst>
-          </p:cNvPr>
+          <p:cNvPr id="5" name="Picture 4" descr="Graph on document with pen"/>
           <p:cNvPicPr>
             <a:picLocks noChangeAspect="1"/>
           </p:cNvPicPr>
           <p:nvPr/>
         </p:nvPicPr>
         <p:blipFill rotWithShape="1">
-          <a:blip r:embed="rId2"/>
+          <a:blip r:embed="rId1"/>
           <a:srcRect l="15628" r="-1" b="-1"/>
-          <a:stretch/>
+          <a:stretch>
+            <a:fillRect/>
+          </a:stretch>
         </p:blipFill>
         <p:spPr>
           <a:xfrm>
@@ -7806,26 +7197,11 @@
       </p:pic>
       <p:sp>
         <p:nvSpPr>
-          <p:cNvPr id="11" name="Rectangle 10">
-            <a:extLst>
-              <a:ext uri="{FF2B5EF4-FFF2-40B4-BE49-F238E27FC236}">
-                <a16:creationId xmlns:a16="http://schemas.microsoft.com/office/drawing/2014/main" id="{E30A3A45-140E-431E-AED0-07EF836310B3}"/>
-              </a:ext>
-              <a:ext uri="{C183D7F6-B498-43B3-948B-1728B52AA6E4}">
-                <adec:decorative xmlns:adec="http://schemas.microsoft.com/office/drawing/2017/decorative" val="1"/>
-              </a:ext>
-            </a:extLst>
-          </p:cNvPr>
+          <p:cNvPr id="11" name="Rectangle 10"/>
           <p:cNvSpPr>
             <a:spLocks noGrp="1" noRot="1" noChangeAspect="1" noMove="1" noResize="1" noEditPoints="1" noAdjustHandles="1" noChangeArrowheads="1" noChangeShapeType="1" noTextEdit="1"/>
           </p:cNvSpPr>
-          <p:nvPr>
-            <p:extLst>
-              <p:ext uri="{386F3935-93C4-4BCD-93E2-E3B085C9AB24}">
-                <p16:designElem xmlns:p16="http://schemas.microsoft.com/office/powerpoint/2015/main" val="1"/>
-              </p:ext>
-            </p:extLst>
-          </p:nvPr>
+          <p:nvPr/>
         </p:nvSpPr>
         <p:spPr>
           <a:xfrm flipH="1">
@@ -7892,26 +7268,11 @@
       </p:sp>
       <p:sp>
         <p:nvSpPr>
-          <p:cNvPr id="13" name="Rectangle 12">
-            <a:extLst>
-              <a:ext uri="{FF2B5EF4-FFF2-40B4-BE49-F238E27FC236}">
-                <a16:creationId xmlns:a16="http://schemas.microsoft.com/office/drawing/2014/main" id="{55D4142C-5077-457F-A6AD-3FECFDB39685}"/>
-              </a:ext>
-              <a:ext uri="{C183D7F6-B498-43B3-948B-1728B52AA6E4}">
-                <adec:decorative xmlns:adec="http://schemas.microsoft.com/office/drawing/2017/decorative" val="1"/>
-              </a:ext>
-            </a:extLst>
-          </p:cNvPr>
+          <p:cNvPr id="13" name="Rectangle 12"/>
           <p:cNvSpPr>
             <a:spLocks noGrp="1" noRot="1" noChangeAspect="1" noMove="1" noResize="1" noEditPoints="1" noAdjustHandles="1" noChangeArrowheads="1" noChangeShapeType="1" noTextEdit="1"/>
           </p:cNvSpPr>
-          <p:nvPr>
-            <p:extLst>
-              <p:ext uri="{386F3935-93C4-4BCD-93E2-E3B085C9AB24}">
-                <p16:designElem xmlns:p16="http://schemas.microsoft.com/office/powerpoint/2015/main" val="1"/>
-              </p:ext>
-            </p:extLst>
-          </p:nvPr>
+          <p:nvPr/>
         </p:nvSpPr>
         <p:spPr>
           <a:xfrm rot="5400000">
@@ -7960,26 +7321,11 @@
       </p:sp>
       <p:sp>
         <p:nvSpPr>
-          <p:cNvPr id="15" name="Rectangle 14">
-            <a:extLst>
-              <a:ext uri="{FF2B5EF4-FFF2-40B4-BE49-F238E27FC236}">
-                <a16:creationId xmlns:a16="http://schemas.microsoft.com/office/drawing/2014/main" id="{7A5F0580-5EE9-419F-96EE-B6529EF6E7D0}"/>
-              </a:ext>
-              <a:ext uri="{C183D7F6-B498-43B3-948B-1728B52AA6E4}">
-                <adec:decorative xmlns:adec="http://schemas.microsoft.com/office/drawing/2017/decorative" val="1"/>
-              </a:ext>
-            </a:extLst>
-          </p:cNvPr>
+          <p:cNvPr id="15" name="Rectangle 14"/>
           <p:cNvSpPr>
             <a:spLocks noGrp="1" noRot="1" noChangeAspect="1" noMove="1" noResize="1" noEditPoints="1" noAdjustHandles="1" noChangeArrowheads="1" noChangeShapeType="1" noTextEdit="1"/>
           </p:cNvSpPr>
-          <p:nvPr>
-            <p:extLst>
-              <p:ext uri="{386F3935-93C4-4BCD-93E2-E3B085C9AB24}">
-                <p16:designElem xmlns:p16="http://schemas.microsoft.com/office/powerpoint/2015/main" val="1"/>
-              </p:ext>
-            </p:extLst>
-          </p:nvPr>
+          <p:nvPr/>
         </p:nvSpPr>
         <p:spPr>
           <a:xfrm>
@@ -8033,7 +7379,6 @@
               <a:buSzTx/>
               <a:buFontTx/>
               <a:buNone/>
-              <a:tabLst/>
               <a:defRPr/>
             </a:pPr>
             <a:endParaRPr kumimoji="0" lang="en-US" sz="1800" b="0" i="0" u="none" strike="noStrike" kern="1200" cap="none" spc="0" normalizeH="0" baseline="0" noProof="0">
@@ -8055,13 +7400,7 @@
       </p:sp>
       <p:sp>
         <p:nvSpPr>
-          <p:cNvPr id="3" name="Content Placeholder 2">
-            <a:extLst>
-              <a:ext uri="{FF2B5EF4-FFF2-40B4-BE49-F238E27FC236}">
-                <a16:creationId xmlns:a16="http://schemas.microsoft.com/office/drawing/2014/main" id="{40EF4243-B725-4BA0-8170-D038ED060FF6}"/>
-              </a:ext>
-            </a:extLst>
-          </p:cNvPr>
+          <p:cNvPr id="3" name="Content Placeholder 2"/>
           <p:cNvSpPr>
             <a:spLocks noGrp="1"/>
           </p:cNvSpPr>
@@ -8099,7 +7438,7 @@
                     </a:srgbClr>
                   </a:outerShdw>
                 </a:effectLst>
-                <a:latin typeface="Gill Sans MT" panose="020B0502020104020203" pitchFamily="34" charset="0"/>
+                <a:latin typeface="Gill Sans MT" pitchFamily="34" charset="0"/>
               </a:rPr>
               <a:t> </a:t>
             </a:r>
@@ -8111,6 +7450,11 @@
               </a:rPr>
               <a:t>PLAN SCHEDULE MANAGEMENT</a:t>
             </a:r>
+            <a:endParaRPr lang="en-US" sz="3600" b="1" dirty="0">
+              <a:solidFill>
+                <a:schemeClr val="bg1"/>
+              </a:solidFill>
+            </a:endParaRPr>
           </a:p>
         </p:txBody>
       </p:sp>
@@ -8149,6 +7493,12 @@
               </a:rPr>
               <a:t>Schedule planning Management covers the processes of defining how the project's schedule will be developed, executed, and controlled. </a:t>
             </a:r>
+            <a:endParaRPr lang="en-US" sz="2400" i="1" dirty="0">
+              <a:solidFill>
+                <a:srgbClr val="FFFF00"/>
+              </a:solidFill>
+              <a:latin typeface="Gill Sans MT" pitchFamily="34" charset="0"/>
+            </a:endParaRPr>
           </a:p>
         </p:txBody>
       </p:sp>
@@ -8160,8 +7510,8 @@
         </p:nvSpPr>
         <p:spPr>
           <a:xfrm>
-            <a:off x="1217699" y="2677810"/>
-            <a:ext cx="6096000" cy="2554545"/>
+            <a:off x="1217930" y="2677795"/>
+            <a:ext cx="6096000" cy="3596005"/>
           </a:xfrm>
           <a:prstGeom prst="rect">
             <a:avLst/>
@@ -8172,7 +7522,7 @@
         </p:spPr>
         <p:txBody>
           <a:bodyPr>
-            <a:spAutoFit/>
+            <a:noAutofit/>
           </a:bodyPr>
           <a:lstStyle/>
           <a:p>
@@ -8187,15 +7537,13 @@
               </a:rPr>
               <a:t>The main objective of Schedule planning Management is to establish the guidelines, methods, and tools that will be used to create and manage the project schedule effectively. </a:t>
             </a:r>
+            <a:endParaRPr lang="en-US" sz="3200" i="1" dirty="0">
+              <a:latin typeface="Gill Sans MT" pitchFamily="34" charset="0"/>
+            </a:endParaRPr>
           </a:p>
         </p:txBody>
       </p:sp>
     </p:spTree>
-    <p:extLst>
-      <p:ext uri="{BB962C8B-B14F-4D97-AF65-F5344CB8AC3E}">
-        <p14:creationId xmlns:p14="http://schemas.microsoft.com/office/powerpoint/2010/main" val="2895785346"/>
-      </p:ext>
-    </p:extLst>
   </p:cSld>
   <p:clrMapOvr>
     <a:masterClrMapping/>
@@ -8222,13 +7570,7 @@
       </p:grpSpPr>
       <p:pic>
         <p:nvPicPr>
-          <p:cNvPr id="5" name="Content Placeholder 4">
-            <a:extLst>
-              <a:ext uri="{FF2B5EF4-FFF2-40B4-BE49-F238E27FC236}">
-                <a16:creationId xmlns:a16="http://schemas.microsoft.com/office/drawing/2014/main" id="{B0B709A1-AA67-4922-8439-4AD1A4A89215}"/>
-              </a:ext>
-            </a:extLst>
-          </p:cNvPr>
+          <p:cNvPr id="5" name="Content Placeholder 4"/>
           <p:cNvPicPr>
             <a:picLocks noGrp="1" noChangeAspect="1"/>
           </p:cNvPicPr>
@@ -8237,7 +7579,7 @@
           </p:nvPr>
         </p:nvPicPr>
         <p:blipFill>
-          <a:blip r:embed="rId2"/>
+          <a:blip r:embed="rId1"/>
           <a:stretch>
             <a:fillRect/>
           </a:stretch>
@@ -8250,11 +7592,6 @@
         </p:spPr>
       </p:pic>
     </p:spTree>
-    <p:extLst>
-      <p:ext uri="{BB962C8B-B14F-4D97-AF65-F5344CB8AC3E}">
-        <p14:creationId xmlns:p14="http://schemas.microsoft.com/office/powerpoint/2010/main" val="616926507"/>
-      </p:ext>
-    </p:extLst>
   </p:cSld>
   <p:clrMapOvr>
     <a:masterClrMapping/>
@@ -8281,13 +7618,7 @@
       </p:grpSpPr>
       <p:sp>
         <p:nvSpPr>
-          <p:cNvPr id="2" name="Title 1">
-            <a:extLst>
-              <a:ext uri="{FF2B5EF4-FFF2-40B4-BE49-F238E27FC236}">
-                <a16:creationId xmlns:a16="http://schemas.microsoft.com/office/drawing/2014/main" id="{4D1914CA-2181-4523-988C-C5E3FD2692CA}"/>
-              </a:ext>
-            </a:extLst>
-          </p:cNvPr>
+          <p:cNvPr id="2" name="Title 1"/>
           <p:cNvSpPr>
             <a:spLocks noGrp="1"/>
           </p:cNvSpPr>
@@ -8304,18 +7635,13 @@
               <a:rPr lang="en-US" dirty="0"/>
               <a:t>SCHEDULE MANAGEMENT PLAN</a:t>
             </a:r>
+            <a:endParaRPr lang="en-US" dirty="0"/>
           </a:p>
         </p:txBody>
       </p:sp>
       <p:pic>
         <p:nvPicPr>
-          <p:cNvPr id="4" name="Content Placeholder 3">
-            <a:extLst>
-              <a:ext uri="{FF2B5EF4-FFF2-40B4-BE49-F238E27FC236}">
-                <a16:creationId xmlns:a16="http://schemas.microsoft.com/office/drawing/2014/main" id="{00B58015-6F22-4F6D-9A15-26AB6C8071DF}"/>
-              </a:ext>
-            </a:extLst>
-          </p:cNvPr>
+          <p:cNvPr id="4" name="Content Placeholder 3"/>
           <p:cNvPicPr>
             <a:picLocks noGrp="1"/>
           </p:cNvPicPr>
@@ -8324,14 +7650,14 @@
           </p:nvPr>
         </p:nvPicPr>
         <p:blipFill>
-          <a:blip r:embed="rId2"/>
+          <a:blip r:embed="rId1"/>
           <a:stretch>
             <a:fillRect/>
           </a:stretch>
         </p:blipFill>
         <p:spPr>
           <a:xfrm>
-            <a:off x="695739" y="1921566"/>
+            <a:off x="618904" y="1339906"/>
             <a:ext cx="10952922" cy="4770782"/>
           </a:xfrm>
           <a:prstGeom prst="rect">
@@ -8340,11 +7666,6 @@
         </p:spPr>
       </p:pic>
     </p:spTree>
-    <p:extLst>
-      <p:ext uri="{BB962C8B-B14F-4D97-AF65-F5344CB8AC3E}">
-        <p14:creationId xmlns:p14="http://schemas.microsoft.com/office/powerpoint/2010/main" val="4225393264"/>
-      </p:ext>
-    </p:extLst>
   </p:cSld>
   <p:clrMapOvr>
     <a:masterClrMapping/>
@@ -8371,13 +7692,7 @@
       </p:grpSpPr>
       <p:sp>
         <p:nvSpPr>
-          <p:cNvPr id="2" name="Title 1">
-            <a:extLst>
-              <a:ext uri="{FF2B5EF4-FFF2-40B4-BE49-F238E27FC236}">
-                <a16:creationId xmlns:a16="http://schemas.microsoft.com/office/drawing/2014/main" id="{4D1914CA-2181-4523-988C-C5E3FD2692CA}"/>
-              </a:ext>
-            </a:extLst>
-          </p:cNvPr>
+          <p:cNvPr id="2" name="Title 1"/>
           <p:cNvSpPr>
             <a:spLocks noGrp="1"/>
           </p:cNvSpPr>
@@ -8399,28 +7714,18 @@
               <a:rPr lang="en-US" dirty="0"/>
               <a:t>KEY TERMINOLOGIES IN PROJECT SCHEDULING</a:t>
             </a:r>
+            <a:endParaRPr lang="en-US" dirty="0"/>
           </a:p>
         </p:txBody>
       </p:sp>
       <p:graphicFrame>
         <p:nvGraphicFramePr>
-          <p:cNvPr id="6" name="Content Placeholder 5">
-            <a:extLst>
-              <a:ext uri="{FF2B5EF4-FFF2-40B4-BE49-F238E27FC236}">
-                <a16:creationId xmlns:a16="http://schemas.microsoft.com/office/drawing/2014/main" id="{0DF3F066-7C46-4B3C-9840-5E27FB01C5BC}"/>
-              </a:ext>
-            </a:extLst>
-          </p:cNvPr>
+          <p:cNvPr id="6" name="Content Placeholder 5"/>
           <p:cNvGraphicFramePr>
             <a:graphicFrameLocks noGrp="1"/>
           </p:cNvGraphicFramePr>
           <p:nvPr>
             <p:ph idx="1"/>
-            <p:extLst>
-              <p:ext uri="{D42A27DB-BD31-4B8C-83A1-F6EECF244321}">
-                <p14:modId xmlns:p14="http://schemas.microsoft.com/office/powerpoint/2010/main" val="3683878153"/>
-              </p:ext>
-            </p:extLst>
           </p:nvPr>
         </p:nvGraphicFramePr>
         <p:xfrm>
@@ -8434,20 +7739,8 @@
                 <a:tableStyleId>{5C22544A-7EE6-4342-B048-85BDC9FD1C3A}</a:tableStyleId>
               </a:tblPr>
               <a:tblGrid>
-                <a:gridCol w="3653458">
-                  <a:extLst>
-                    <a:ext uri="{9D8B030D-6E8A-4147-A177-3AD203B41FA5}">
-                      <a16:colId xmlns:a16="http://schemas.microsoft.com/office/drawing/2014/main" val="2431840203"/>
-                    </a:ext>
-                  </a:extLst>
-                </a:gridCol>
-                <a:gridCol w="7662242">
-                  <a:extLst>
-                    <a:ext uri="{9D8B030D-6E8A-4147-A177-3AD203B41FA5}">
-                      <a16:colId xmlns:a16="http://schemas.microsoft.com/office/drawing/2014/main" val="3765361637"/>
-                    </a:ext>
-                  </a:extLst>
-                </a:gridCol>
+                <a:gridCol w="3653458"/>
+                <a:gridCol w="7662242"/>
               </a:tblGrid>
               <a:tr h="293231">
                 <a:tc>
@@ -8514,11 +7807,6 @@
                   </a:txBody>
                   <a:tcPr marL="9525" marR="9525" marT="9525" marB="9525" anchor="ctr"/>
                 </a:tc>
-                <a:extLst>
-                  <a:ext uri="{0D108BD9-81ED-4DB2-BD59-A6C34878D82A}">
-                    <a16:rowId xmlns:a16="http://schemas.microsoft.com/office/drawing/2014/main" val="954216516"/>
-                  </a:ext>
-                </a:extLst>
               </a:tr>
               <a:tr h="293231">
                 <a:tc>
@@ -8585,11 +7873,6 @@
                   </a:txBody>
                   <a:tcPr marL="9525" marR="9525" marT="9525" marB="9525" anchor="ctr"/>
                 </a:tc>
-                <a:extLst>
-                  <a:ext uri="{0D108BD9-81ED-4DB2-BD59-A6C34878D82A}">
-                    <a16:rowId xmlns:a16="http://schemas.microsoft.com/office/drawing/2014/main" val="2219646437"/>
-                  </a:ext>
-                </a:extLst>
               </a:tr>
               <a:tr h="577368">
                 <a:tc>
@@ -8656,11 +7939,6 @@
                   </a:txBody>
                   <a:tcPr marL="9525" marR="9525" marT="9525" marB="9525" anchor="ctr"/>
                 </a:tc>
-                <a:extLst>
-                  <a:ext uri="{0D108BD9-81ED-4DB2-BD59-A6C34878D82A}">
-                    <a16:rowId xmlns:a16="http://schemas.microsoft.com/office/drawing/2014/main" val="1294581435"/>
-                  </a:ext>
-                </a:extLst>
               </a:tr>
               <a:tr h="293231">
                 <a:tc>
@@ -8727,11 +8005,6 @@
                   </a:txBody>
                   <a:tcPr marL="9525" marR="9525" marT="9525" marB="9525" anchor="ctr"/>
                 </a:tc>
-                <a:extLst>
-                  <a:ext uri="{0D108BD9-81ED-4DB2-BD59-A6C34878D82A}">
-                    <a16:rowId xmlns:a16="http://schemas.microsoft.com/office/drawing/2014/main" val="662906010"/>
-                  </a:ext>
-                </a:extLst>
               </a:tr>
               <a:tr h="293231">
                 <a:tc>
@@ -8798,11 +8071,6 @@
                   </a:txBody>
                   <a:tcPr marL="9525" marR="9525" marT="9525" marB="9525" anchor="ctr"/>
                 </a:tc>
-                <a:extLst>
-                  <a:ext uri="{0D108BD9-81ED-4DB2-BD59-A6C34878D82A}">
-                    <a16:rowId xmlns:a16="http://schemas.microsoft.com/office/drawing/2014/main" val="4282510205"/>
-                  </a:ext>
-                </a:extLst>
               </a:tr>
               <a:tr h="293231">
                 <a:tc>
@@ -8869,11 +8137,6 @@
                   </a:txBody>
                   <a:tcPr marL="9525" marR="9525" marT="9525" marB="9525" anchor="ctr"/>
                 </a:tc>
-                <a:extLst>
-                  <a:ext uri="{0D108BD9-81ED-4DB2-BD59-A6C34878D82A}">
-                    <a16:rowId xmlns:a16="http://schemas.microsoft.com/office/drawing/2014/main" val="3504552559"/>
-                  </a:ext>
-                </a:extLst>
               </a:tr>
               <a:tr h="293231">
                 <a:tc>
@@ -8940,11 +8203,6 @@
                   </a:txBody>
                   <a:tcPr marL="9525" marR="9525" marT="9525" marB="9525" anchor="ctr"/>
                 </a:tc>
-                <a:extLst>
-                  <a:ext uri="{0D108BD9-81ED-4DB2-BD59-A6C34878D82A}">
-                    <a16:rowId xmlns:a16="http://schemas.microsoft.com/office/drawing/2014/main" val="807750001"/>
-                  </a:ext>
-                </a:extLst>
               </a:tr>
               <a:tr h="293231">
                 <a:tc>
@@ -9011,11 +8269,6 @@
                   </a:txBody>
                   <a:tcPr marL="9525" marR="9525" marT="9525" marB="9525" anchor="ctr"/>
                 </a:tc>
-                <a:extLst>
-                  <a:ext uri="{0D108BD9-81ED-4DB2-BD59-A6C34878D82A}">
-                    <a16:rowId xmlns:a16="http://schemas.microsoft.com/office/drawing/2014/main" val="4180122242"/>
-                  </a:ext>
-                </a:extLst>
               </a:tr>
               <a:tr h="577368">
                 <a:tc>
@@ -9082,11 +8335,6 @@
                   </a:txBody>
                   <a:tcPr marL="9525" marR="9525" marT="9525" marB="9525" anchor="ctr"/>
                 </a:tc>
-                <a:extLst>
-                  <a:ext uri="{0D108BD9-81ED-4DB2-BD59-A6C34878D82A}">
-                    <a16:rowId xmlns:a16="http://schemas.microsoft.com/office/drawing/2014/main" val="2683184169"/>
-                  </a:ext>
-                </a:extLst>
               </a:tr>
               <a:tr h="293231">
                 <a:tc>
@@ -9153,11 +8401,6 @@
                   </a:txBody>
                   <a:tcPr marL="9525" marR="9525" marT="9525" marB="9525" anchor="ctr"/>
                 </a:tc>
-                <a:extLst>
-                  <a:ext uri="{0D108BD9-81ED-4DB2-BD59-A6C34878D82A}">
-                    <a16:rowId xmlns:a16="http://schemas.microsoft.com/office/drawing/2014/main" val="2247099122"/>
-                  </a:ext>
-                </a:extLst>
               </a:tr>
               <a:tr h="577368">
                 <a:tc>
@@ -9224,11 +8467,6 @@
                   </a:txBody>
                   <a:tcPr marL="9525" marR="9525" marT="9525" marB="9525" anchor="ctr"/>
                 </a:tc>
-                <a:extLst>
-                  <a:ext uri="{0D108BD9-81ED-4DB2-BD59-A6C34878D82A}">
-                    <a16:rowId xmlns:a16="http://schemas.microsoft.com/office/drawing/2014/main" val="2338188066"/>
-                  </a:ext>
-                </a:extLst>
               </a:tr>
               <a:tr h="577368">
                 <a:tc>
@@ -9295,11 +8533,6 @@
                   </a:txBody>
                   <a:tcPr marL="9525" marR="9525" marT="9525" marB="9525" anchor="ctr"/>
                 </a:tc>
-                <a:extLst>
-                  <a:ext uri="{0D108BD9-81ED-4DB2-BD59-A6C34878D82A}">
-                    <a16:rowId xmlns:a16="http://schemas.microsoft.com/office/drawing/2014/main" val="3012627504"/>
-                  </a:ext>
-                </a:extLst>
               </a:tr>
               <a:tr h="293231">
                 <a:tc>
@@ -9366,11 +8599,6 @@
                   </a:txBody>
                   <a:tcPr marL="9525" marR="9525" marT="9525" marB="9525" anchor="ctr"/>
                 </a:tc>
-                <a:extLst>
-                  <a:ext uri="{0D108BD9-81ED-4DB2-BD59-A6C34878D82A}">
-                    <a16:rowId xmlns:a16="http://schemas.microsoft.com/office/drawing/2014/main" val="337809033"/>
-                  </a:ext>
-                </a:extLst>
               </a:tr>
               <a:tr h="293231">
                 <a:tc>
@@ -9437,11 +8665,6 @@
                   </a:txBody>
                   <a:tcPr marL="9525" marR="9525" marT="9525" marB="9525" anchor="ctr"/>
                 </a:tc>
-                <a:extLst>
-                  <a:ext uri="{0D108BD9-81ED-4DB2-BD59-A6C34878D82A}">
-                    <a16:rowId xmlns:a16="http://schemas.microsoft.com/office/drawing/2014/main" val="1123961048"/>
-                  </a:ext>
-                </a:extLst>
               </a:tr>
               <a:tr h="293231">
                 <a:tc>
@@ -9508,22 +8731,12 @@
                   </a:txBody>
                   <a:tcPr marL="9525" marR="9525" marT="9525" marB="9525" anchor="ctr"/>
                 </a:tc>
-                <a:extLst>
-                  <a:ext uri="{0D108BD9-81ED-4DB2-BD59-A6C34878D82A}">
-                    <a16:rowId xmlns:a16="http://schemas.microsoft.com/office/drawing/2014/main" val="1026738150"/>
-                  </a:ext>
-                </a:extLst>
               </a:tr>
             </a:tbl>
           </a:graphicData>
         </a:graphic>
       </p:graphicFrame>
     </p:spTree>
-    <p:extLst>
-      <p:ext uri="{BB962C8B-B14F-4D97-AF65-F5344CB8AC3E}">
-        <p14:creationId xmlns:p14="http://schemas.microsoft.com/office/powerpoint/2010/main" val="304025711"/>
-      </p:ext>
-    </p:extLst>
   </p:cSld>
   <p:clrMapOvr>
     <a:masterClrMapping/>
@@ -9550,13 +8763,7 @@
       </p:grpSpPr>
       <p:sp>
         <p:nvSpPr>
-          <p:cNvPr id="23" name="Rectangle 22">
-            <a:extLst>
-              <a:ext uri="{FF2B5EF4-FFF2-40B4-BE49-F238E27FC236}">
-                <a16:creationId xmlns:a16="http://schemas.microsoft.com/office/drawing/2014/main" id="{16DCBB73-A4E9-4433-8193-E9D7FFA79C22}"/>
-              </a:ext>
-            </a:extLst>
-          </p:cNvPr>
+          <p:cNvPr id="23" name="Rectangle 22"/>
           <p:cNvSpPr/>
           <p:nvPr/>
         </p:nvSpPr>
@@ -9634,13 +8841,7 @@
       </p:sp>
       <p:sp>
         <p:nvSpPr>
-          <p:cNvPr id="22" name="Rectangle 21">
-            <a:extLst>
-              <a:ext uri="{FF2B5EF4-FFF2-40B4-BE49-F238E27FC236}">
-                <a16:creationId xmlns:a16="http://schemas.microsoft.com/office/drawing/2014/main" id="{EA79F623-C4E3-4E12-AFF5-ACEE8185E557}"/>
-              </a:ext>
-            </a:extLst>
-          </p:cNvPr>
+          <p:cNvPr id="22" name="Rectangle 21"/>
           <p:cNvSpPr/>
           <p:nvPr/>
         </p:nvSpPr>
@@ -9717,13 +8918,7 @@
       </p:sp>
       <p:sp>
         <p:nvSpPr>
-          <p:cNvPr id="6" name="Rectangle 5">
-            <a:extLst>
-              <a:ext uri="{FF2B5EF4-FFF2-40B4-BE49-F238E27FC236}">
-                <a16:creationId xmlns:a16="http://schemas.microsoft.com/office/drawing/2014/main" id="{3CBE5B84-D497-4D80-B7F1-95AF0202EE16}"/>
-              </a:ext>
-            </a:extLst>
-          </p:cNvPr>
+          <p:cNvPr id="6" name="Rectangle 5"/>
           <p:cNvSpPr/>
           <p:nvPr/>
         </p:nvSpPr>
@@ -9808,13 +9003,7 @@
       </p:sp>
       <p:sp>
         <p:nvSpPr>
-          <p:cNvPr id="4" name="Rectangle 3">
-            <a:extLst>
-              <a:ext uri="{FF2B5EF4-FFF2-40B4-BE49-F238E27FC236}">
-                <a16:creationId xmlns:a16="http://schemas.microsoft.com/office/drawing/2014/main" id="{A409639D-38A0-4B87-8843-B050C1376911}"/>
-              </a:ext>
-            </a:extLst>
-          </p:cNvPr>
+          <p:cNvPr id="4" name="Rectangle 3"/>
           <p:cNvSpPr/>
           <p:nvPr/>
         </p:nvSpPr>
@@ -9943,6 +9132,11 @@
               </a:rPr>
               <a:t>A</a:t>
             </a:r>
+            <a:endParaRPr lang="en-US" sz="3200" dirty="0">
+              <a:solidFill>
+                <a:schemeClr val="bg1"/>
+              </a:solidFill>
+            </a:endParaRPr>
           </a:p>
         </p:txBody>
       </p:sp>
@@ -9995,6 +9189,11 @@
               </a:rPr>
               <a:t>B</a:t>
             </a:r>
+            <a:endParaRPr lang="en-US" sz="3200" dirty="0">
+              <a:solidFill>
+                <a:schemeClr val="bg1"/>
+              </a:solidFill>
+            </a:endParaRPr>
           </a:p>
         </p:txBody>
       </p:sp>
@@ -10042,6 +9241,11 @@
               </a:rPr>
               <a:t>A</a:t>
             </a:r>
+            <a:endParaRPr lang="en-US" sz="3600" dirty="0">
+              <a:solidFill>
+                <a:schemeClr val="bg1"/>
+              </a:solidFill>
+            </a:endParaRPr>
           </a:p>
         </p:txBody>
       </p:sp>
@@ -10089,6 +9293,11 @@
               </a:rPr>
               <a:t>B</a:t>
             </a:r>
+            <a:endParaRPr lang="en-US" sz="3600" dirty="0">
+              <a:solidFill>
+                <a:schemeClr val="bg1"/>
+              </a:solidFill>
+            </a:endParaRPr>
           </a:p>
         </p:txBody>
       </p:sp>
@@ -10136,6 +9345,11 @@
               </a:rPr>
               <a:t>B</a:t>
             </a:r>
+            <a:endParaRPr lang="en-US" sz="3600" dirty="0">
+              <a:solidFill>
+                <a:schemeClr val="bg1"/>
+              </a:solidFill>
+            </a:endParaRPr>
           </a:p>
         </p:txBody>
       </p:sp>
@@ -10183,6 +9397,11 @@
               </a:rPr>
               <a:t>A</a:t>
             </a:r>
+            <a:endParaRPr lang="en-US" sz="3600" dirty="0">
+              <a:solidFill>
+                <a:schemeClr val="bg1"/>
+              </a:solidFill>
+            </a:endParaRPr>
           </a:p>
         </p:txBody>
       </p:sp>
@@ -10230,6 +9449,11 @@
               </a:rPr>
               <a:t>B</a:t>
             </a:r>
+            <a:endParaRPr lang="en-US" sz="3600" dirty="0">
+              <a:solidFill>
+                <a:schemeClr val="bg1"/>
+              </a:solidFill>
+            </a:endParaRPr>
           </a:p>
         </p:txBody>
       </p:sp>
@@ -10277,6 +9501,11 @@
               </a:rPr>
               <a:t>A</a:t>
             </a:r>
+            <a:endParaRPr lang="en-US" sz="3600" dirty="0">
+              <a:solidFill>
+                <a:schemeClr val="bg1"/>
+              </a:solidFill>
+            </a:endParaRPr>
           </a:p>
         </p:txBody>
       </p:sp>
@@ -10826,6 +10055,7 @@
               <a:rPr lang="en-US" sz="2400" dirty="0"/>
               <a:t>The most common dependency</a:t>
             </a:r>
+            <a:endParaRPr lang="en-US" sz="2400" dirty="0"/>
           </a:p>
         </p:txBody>
       </p:sp>
@@ -10890,15 +10120,13 @@
               </a:rPr>
               <a:t>THE FOUR TYPES OF LOGICAL RELATIONSHIPS</a:t>
             </a:r>
+            <a:endParaRPr lang="en-US" sz="2400" b="1" dirty="0">
+              <a:latin typeface="Gill Sans MT" pitchFamily="34" charset="0"/>
+            </a:endParaRPr>
           </a:p>
         </p:txBody>
       </p:sp>
     </p:spTree>
-    <p:extLst>
-      <p:ext uri="{BB962C8B-B14F-4D97-AF65-F5344CB8AC3E}">
-        <p14:creationId xmlns:p14="http://schemas.microsoft.com/office/powerpoint/2010/main" val="2033761775"/>
-      </p:ext>
-    </p:extLst>
   </p:cSld>
   <p:clrMapOvr>
     <a:masterClrMapping/>
@@ -13609,13 +12837,7 @@
       </p:grpSpPr>
       <p:sp>
         <p:nvSpPr>
-          <p:cNvPr id="2" name="Rectangle 1">
-            <a:extLst>
-              <a:ext uri="{FF2B5EF4-FFF2-40B4-BE49-F238E27FC236}">
-                <a16:creationId xmlns:a16="http://schemas.microsoft.com/office/drawing/2014/main" id="{ED2740A0-9D51-40D9-98F8-C17A27E3B780}"/>
-              </a:ext>
-            </a:extLst>
-          </p:cNvPr>
+          <p:cNvPr id="2" name="Rectangle 1"/>
           <p:cNvSpPr/>
           <p:nvPr/>
         </p:nvSpPr>
@@ -13634,7 +12856,7 @@
           </a:bodyPr>
           <a:lstStyle/>
           <a:p>
-            <a:pPr algn="ctr" defTabSz="859536">
+            <a:pPr algn="ctr" defTabSz="859790">
               <a:spcAft>
                 <a:spcPts val="600"/>
               </a:spcAft>
@@ -13657,9 +12879,24 @@
               </a:rPr>
               <a:t>DEPENDECY COMBINATION WITHIN A NETWORK</a:t>
             </a:r>
-          </a:p>
-          <a:p>
-            <a:pPr algn="ctr" defTabSz="859536">
+            <a:endParaRPr lang="en-US" sz="2400" b="1" kern="1200" dirty="0">
+              <a:solidFill>
+                <a:srgbClr val="C00000"/>
+              </a:solidFill>
+              <a:effectLst>
+                <a:outerShdw blurRad="38100" dist="38100" dir="2700000" algn="tl">
+                  <a:srgbClr val="000000">
+                    <a:alpha val="43137"/>
+                  </a:srgbClr>
+                </a:outerShdw>
+              </a:effectLst>
+              <a:latin typeface="+mn-lt"/>
+              <a:ea typeface="+mn-ea"/>
+              <a:cs typeface="+mn-cs"/>
+            </a:endParaRPr>
+          </a:p>
+          <a:p>
+            <a:pPr algn="ctr" defTabSz="859790">
               <a:spcAft>
                 <a:spcPts val="600"/>
               </a:spcAft>
@@ -13681,7 +12918,7 @@
             </a:endParaRPr>
           </a:p>
           <a:p>
-            <a:pPr algn="just" defTabSz="859536">
+            <a:pPr algn="just" defTabSz="859790">
               <a:spcAft>
                 <a:spcPts val="600"/>
               </a:spcAft>
@@ -13731,14 +12968,20 @@
               </a:rPr>
               <a:t> (lag finish) </a:t>
             </a:r>
-          </a:p>
-          <a:p>
-            <a:pPr algn="just" defTabSz="859536">
+            <a:endParaRPr lang="en-US" sz="2800" kern="1200" dirty="0">
+              <a:solidFill>
+                <a:schemeClr val="tx1"/>
+              </a:solidFill>
+              <a:latin typeface="Gill Sans MT" pitchFamily="34" charset="0"/>
+            </a:endParaRPr>
+          </a:p>
+          <a:p>
+            <a:pPr algn="just" defTabSz="859790">
               <a:spcAft>
                 <a:spcPts val="600"/>
               </a:spcAft>
             </a:pPr>
-            <a:endParaRPr lang="en-US" sz="2256" kern="1200" dirty="0">
+            <a:endParaRPr lang="en-US" sz="2255" kern="1200" dirty="0">
               <a:solidFill>
                 <a:schemeClr val="tx1"/>
               </a:solidFill>
@@ -13748,12 +12991,12 @@
             </a:endParaRPr>
           </a:p>
           <a:p>
-            <a:pPr algn="just" defTabSz="859536">
+            <a:pPr algn="just" defTabSz="859790">
               <a:spcAft>
                 <a:spcPts val="600"/>
               </a:spcAft>
             </a:pPr>
-            <a:endParaRPr lang="en-US" sz="2256" kern="1200" dirty="0">
+            <a:endParaRPr lang="en-US" sz="2255" kern="1200" dirty="0">
               <a:solidFill>
                 <a:schemeClr val="tx1"/>
               </a:solidFill>
@@ -13763,12 +13006,12 @@
             </a:endParaRPr>
           </a:p>
           <a:p>
-            <a:pPr algn="just" defTabSz="859536">
+            <a:pPr algn="just" defTabSz="859790">
               <a:spcAft>
                 <a:spcPts val="600"/>
               </a:spcAft>
             </a:pPr>
-            <a:endParaRPr lang="en-US" sz="2256" kern="1200" dirty="0">
+            <a:endParaRPr lang="en-US" sz="2255" kern="1200" dirty="0">
               <a:solidFill>
                 <a:schemeClr val="tx1"/>
               </a:solidFill>
@@ -13778,7 +13021,7 @@
             </a:endParaRPr>
           </a:p>
           <a:p>
-            <a:pPr algn="just" defTabSz="859536">
+            <a:pPr algn="just" defTabSz="859790">
               <a:spcAft>
                 <a:spcPts val="600"/>
               </a:spcAft>
@@ -13793,13 +13036,13 @@
             </a:endParaRPr>
           </a:p>
           <a:p>
-            <a:pPr algn="just" defTabSz="859536">
+            <a:pPr algn="just" defTabSz="859790">
               <a:spcAft>
                 <a:spcPts val="600"/>
               </a:spcAft>
             </a:pPr>
             <a:r>
-              <a:rPr lang="en-US" sz="2256" kern="1200" dirty="0">
+              <a:rPr lang="en-US" sz="2255" kern="1200" dirty="0">
                 <a:solidFill>
                   <a:schemeClr val="tx1"/>
                 </a:solidFill>
@@ -13819,18 +13062,12 @@
       </p:sp>
       <p:pic>
         <p:nvPicPr>
-          <p:cNvPr id="6" name="Picture 5">
-            <a:extLst>
-              <a:ext uri="{FF2B5EF4-FFF2-40B4-BE49-F238E27FC236}">
-                <a16:creationId xmlns:a16="http://schemas.microsoft.com/office/drawing/2014/main" id="{53672469-C46D-4519-A182-6E9F6B4317A3}"/>
-              </a:ext>
-            </a:extLst>
-          </p:cNvPr>
+          <p:cNvPr id="6" name="Picture 5"/>
           <p:cNvPicPr/>
           <p:nvPr/>
         </p:nvPicPr>
         <p:blipFill>
-          <a:blip r:embed="rId2"/>
+          <a:blip r:embed="rId1"/>
           <a:stretch>
             <a:fillRect/>
           </a:stretch>
@@ -13846,11 +13083,6 @@
         </p:spPr>
       </p:pic>
     </p:spTree>
-    <p:extLst>
-      <p:ext uri="{BB962C8B-B14F-4D97-AF65-F5344CB8AC3E}">
-        <p14:creationId xmlns:p14="http://schemas.microsoft.com/office/powerpoint/2010/main" val="2231251495"/>
-      </p:ext>
-    </p:extLst>
   </p:cSld>
   <p:clrMapOvr>
     <a:masterClrMapping/>
@@ -13915,6 +13147,7 @@
               <a:rPr lang="en-US" sz="2000" b="1" dirty="0"/>
               <a:t>START</a:t>
             </a:r>
+            <a:endParaRPr lang="en-US" sz="2000" b="1" dirty="0"/>
           </a:p>
         </p:txBody>
       </p:sp>
@@ -13956,6 +13189,7 @@
               <a:rPr lang="en-US" sz="2800" dirty="0"/>
               <a:t>A</a:t>
             </a:r>
+            <a:endParaRPr lang="en-US" sz="2800" dirty="0"/>
           </a:p>
         </p:txBody>
       </p:sp>
@@ -13999,6 +13233,7 @@
               <a:rPr lang="en-US" sz="2800" dirty="0"/>
               <a:t>B</a:t>
             </a:r>
+            <a:endParaRPr lang="en-US" sz="2800" dirty="0"/>
           </a:p>
         </p:txBody>
       </p:sp>
@@ -14042,6 +13277,7 @@
               <a:rPr lang="en-US" sz="2800" dirty="0"/>
               <a:t>H</a:t>
             </a:r>
+            <a:endParaRPr lang="en-US" sz="2800" dirty="0"/>
           </a:p>
         </p:txBody>
       </p:sp>
@@ -14085,6 +13321,7 @@
               <a:rPr lang="en-US" sz="3200" dirty="0"/>
               <a:t>F</a:t>
             </a:r>
+            <a:endParaRPr lang="en-US" sz="3200" dirty="0"/>
           </a:p>
         </p:txBody>
       </p:sp>
@@ -14128,6 +13365,7 @@
               <a:rPr lang="en-US" sz="2800" dirty="0"/>
               <a:t>G</a:t>
             </a:r>
+            <a:endParaRPr lang="en-US" sz="2800" dirty="0"/>
           </a:p>
         </p:txBody>
       </p:sp>
@@ -14169,6 +13407,7 @@
               <a:rPr lang="en-US" sz="2800" dirty="0"/>
               <a:t>E</a:t>
             </a:r>
+            <a:endParaRPr lang="en-US" sz="2800" dirty="0"/>
           </a:p>
         </p:txBody>
       </p:sp>
@@ -14210,6 +13449,7 @@
               <a:rPr lang="en-US" sz="3200" dirty="0"/>
               <a:t>D</a:t>
             </a:r>
+            <a:endParaRPr lang="en-US" sz="3200" dirty="0"/>
           </a:p>
         </p:txBody>
       </p:sp>
@@ -14251,6 +13491,7 @@
               <a:rPr lang="en-US" sz="3200" dirty="0"/>
               <a:t>C</a:t>
             </a:r>
+            <a:endParaRPr lang="en-US" sz="3200" dirty="0"/>
           </a:p>
         </p:txBody>
       </p:sp>
@@ -14294,6 +13535,7 @@
               <a:rPr lang="en-US" sz="2400" dirty="0"/>
               <a:t>FINISH</a:t>
             </a:r>
+            <a:endParaRPr lang="en-US" sz="2400" dirty="0"/>
           </a:p>
         </p:txBody>
       </p:sp>
@@ -14792,6 +14034,7 @@
               <a:rPr lang="en-US" sz="2400" b="1" dirty="0"/>
               <a:t>. </a:t>
             </a:r>
+            <a:endParaRPr lang="en-US" sz="2400" b="1" dirty="0"/>
           </a:p>
         </p:txBody>
       </p:sp>
@@ -14804,7 +14047,7 @@
           <p:nvPr/>
         </p:nvPicPr>
         <p:blipFill>
-          <a:blip r:embed="rId3">
+          <a:blip r:embed="rId1">
             <a:extLst>
               <a:ext uri="{28A0092B-C50C-407E-A947-70E740481C1C}">
                 <a14:useLocalDpi xmlns:a14="http://schemas.microsoft.com/office/drawing/2010/main" val="0"/>
@@ -14926,15 +14169,11 @@
               <a:rPr lang="en-US" dirty="0"/>
               <a:t>Activity on Node (AON)</a:t>
             </a:r>
+            <a:endParaRPr lang="en-US" dirty="0"/>
           </a:p>
         </p:txBody>
       </p:sp>
     </p:spTree>
-    <p:extLst>
-      <p:ext uri="{BB962C8B-B14F-4D97-AF65-F5344CB8AC3E}">
-        <p14:creationId xmlns:p14="http://schemas.microsoft.com/office/powerpoint/2010/main" val="2011259387"/>
-      </p:ext>
-    </p:extLst>
   </p:cSld>
   <p:clrMapOvr>
     <a:masterClrMapping/>
@@ -15018,23 +14257,6 @@
         <a:font script="Viet" typeface="Times New Roman"/>
         <a:font script="Uigh" typeface="Microsoft Uighur"/>
         <a:font script="Geor" typeface="Sylfaen"/>
-        <a:font script="Armn" typeface="Arial"/>
-        <a:font script="Bugi" typeface="Leelawadee UI"/>
-        <a:font script="Bopo" typeface="Microsoft JhengHei"/>
-        <a:font script="Java" typeface="Javanese Text"/>
-        <a:font script="Lisu" typeface="Segoe UI"/>
-        <a:font script="Mymr" typeface="Myanmar Text"/>
-        <a:font script="Nkoo" typeface="Ebrima"/>
-        <a:font script="Olck" typeface="Nirmala UI"/>
-        <a:font script="Osma" typeface="Ebrima"/>
-        <a:font script="Phag" typeface="Phagspa"/>
-        <a:font script="Syrn" typeface="Estrangelo Edessa"/>
-        <a:font script="Syrj" typeface="Estrangelo Edessa"/>
-        <a:font script="Syre" typeface="Estrangelo Edessa"/>
-        <a:font script="Sora" typeface="Nirmala UI"/>
-        <a:font script="Tale" typeface="Microsoft Tai Le"/>
-        <a:font script="Talu" typeface="Microsoft New Tai Lue"/>
-        <a:font script="Tfng" typeface="Ebrima"/>
       </a:majorFont>
       <a:minorFont>
         <a:latin typeface="Calibri"/>
@@ -15070,23 +14292,6 @@
         <a:font script="Viet" typeface="Arial"/>
         <a:font script="Uigh" typeface="Microsoft Uighur"/>
         <a:font script="Geor" typeface="Sylfaen"/>
-        <a:font script="Armn" typeface="Arial"/>
-        <a:font script="Bugi" typeface="Leelawadee UI"/>
-        <a:font script="Bopo" typeface="Microsoft JhengHei"/>
-        <a:font script="Java" typeface="Javanese Text"/>
-        <a:font script="Lisu" typeface="Segoe UI"/>
-        <a:font script="Mymr" typeface="Myanmar Text"/>
-        <a:font script="Nkoo" typeface="Ebrima"/>
-        <a:font script="Olck" typeface="Nirmala UI"/>
-        <a:font script="Osma" typeface="Ebrima"/>
-        <a:font script="Phag" typeface="Phagspa"/>
-        <a:font script="Syrn" typeface="Estrangelo Edessa"/>
-        <a:font script="Syrj" typeface="Estrangelo Edessa"/>
-        <a:font script="Syre" typeface="Estrangelo Edessa"/>
-        <a:font script="Sora" typeface="Nirmala UI"/>
-        <a:font script="Tale" typeface="Microsoft Tai Le"/>
-        <a:font script="Talu" typeface="Microsoft New Tai Lue"/>
-        <a:font script="Tfng" typeface="Ebrima"/>
       </a:minorFont>
     </a:fontScheme>
     <a:fmtScheme name="Office">
@@ -15227,8 +14432,6 @@
       </a:bgFillStyleLst>
     </a:fmtScheme>
   </a:themeElements>
-  <a:objectDefaults/>
-  <a:extraClrSchemeLst/>
   <a:extLst>
     <a:ext uri="{05A4C25C-085E-4340-85A3-A5531E510DB2}">
       <thm15:themeFamily xmlns:thm15="http://schemas.microsoft.com/office/thememl/2012/main" name="Office Theme" id="{62F939B6-93AF-4DB8-9C6B-D6C7DFDC589F}" vid="{4A3C46E8-61CC-4603-A589-7422A47A8E4A}"/>
@@ -15313,23 +14516,6 @@
         <a:font script="Viet" typeface="Times New Roman"/>
         <a:font script="Uigh" typeface="Microsoft Uighur"/>
         <a:font script="Geor" typeface="Sylfaen"/>
-        <a:font script="Armn" typeface="Arial"/>
-        <a:font script="Bugi" typeface="Leelawadee UI"/>
-        <a:font script="Bopo" typeface="Microsoft JhengHei"/>
-        <a:font script="Java" typeface="Javanese Text"/>
-        <a:font script="Lisu" typeface="Segoe UI"/>
-        <a:font script="Mymr" typeface="Myanmar Text"/>
-        <a:font script="Nkoo" typeface="Ebrima"/>
-        <a:font script="Olck" typeface="Nirmala UI"/>
-        <a:font script="Osma" typeface="Ebrima"/>
-        <a:font script="Phag" typeface="Phagspa"/>
-        <a:font script="Syrn" typeface="Estrangelo Edessa"/>
-        <a:font script="Syrj" typeface="Estrangelo Edessa"/>
-        <a:font script="Syre" typeface="Estrangelo Edessa"/>
-        <a:font script="Sora" typeface="Nirmala UI"/>
-        <a:font script="Tale" typeface="Microsoft Tai Le"/>
-        <a:font script="Talu" typeface="Microsoft New Tai Lue"/>
-        <a:font script="Tfng" typeface="Ebrima"/>
       </a:majorFont>
       <a:minorFont>
         <a:latin typeface="Calibri"/>
@@ -15365,23 +14551,6 @@
         <a:font script="Viet" typeface="Arial"/>
         <a:font script="Uigh" typeface="Microsoft Uighur"/>
         <a:font script="Geor" typeface="Sylfaen"/>
-        <a:font script="Armn" typeface="Arial"/>
-        <a:font script="Bugi" typeface="Leelawadee UI"/>
-        <a:font script="Bopo" typeface="Microsoft JhengHei"/>
-        <a:font script="Java" typeface="Javanese Text"/>
-        <a:font script="Lisu" typeface="Segoe UI"/>
-        <a:font script="Mymr" typeface="Myanmar Text"/>
-        <a:font script="Nkoo" typeface="Ebrima"/>
-        <a:font script="Olck" typeface="Nirmala UI"/>
-        <a:font script="Osma" typeface="Ebrima"/>
-        <a:font script="Phag" typeface="Phagspa"/>
-        <a:font script="Syrn" typeface="Estrangelo Edessa"/>
-        <a:font script="Syrj" typeface="Estrangelo Edessa"/>
-        <a:font script="Syre" typeface="Estrangelo Edessa"/>
-        <a:font script="Sora" typeface="Nirmala UI"/>
-        <a:font script="Tale" typeface="Microsoft Tai Le"/>
-        <a:font script="Talu" typeface="Microsoft New Tai Lue"/>
-        <a:font script="Tfng" typeface="Ebrima"/>
       </a:minorFont>
     </a:fontScheme>
     <a:fmtScheme name="Office">
@@ -15522,8 +14691,6 @@
       </a:bgFillStyleLst>
     </a:fmtScheme>
   </a:themeElements>
-  <a:objectDefaults/>
-  <a:extraClrSchemeLst/>
   <a:extLst>
     <a:ext uri="{05A4C25C-085E-4340-85A3-A5531E510DB2}">
       <thm15:themeFamily xmlns:thm15="http://schemas.microsoft.com/office/thememl/2012/main" name="Office Theme" id="{62F939B6-93AF-4DB8-9C6B-D6C7DFDC589F}" vid="{4A3C46E8-61CC-4603-A589-7422A47A8E4A}"/>

</xml_diff>